<commit_message>
Update the course in development
</commit_message>
<xml_diff>
--- a/HCWMPA&S/Slides/6. Low Precision.pptx
+++ b/HCWMPA&S/Slides/6. Low Precision.pptx
@@ -5,10 +5,10 @@
     <p:sldMasterId id="2147483651" r:id="rId4"/>
   </p:sldMasterIdLst>
   <p:notesMasterIdLst>
-    <p:notesMasterId r:id="rId33"/>
+    <p:notesMasterId r:id="rId34"/>
   </p:notesMasterIdLst>
   <p:handoutMasterIdLst>
-    <p:handoutMasterId r:id="rId34"/>
+    <p:handoutMasterId r:id="rId35"/>
   </p:handoutMasterIdLst>
   <p:sldIdLst>
     <p:sldId id="286" r:id="rId5"/>
@@ -38,7 +38,8 @@
     <p:sldId id="640" r:id="rId29"/>
     <p:sldId id="608" r:id="rId30"/>
     <p:sldId id="642" r:id="rId31"/>
-    <p:sldId id="353" r:id="rId32"/>
+    <p:sldId id="643" r:id="rId32"/>
+    <p:sldId id="353" r:id="rId33"/>
   </p:sldIdLst>
   <p:sldSz cx="9144000" cy="6858000" type="screen4x3"/>
   <p:notesSz cx="7010400" cy="9296400"/>
@@ -203,7 +204,7 @@
 <file path=ppt/revisionInfo.xml><?xml version="1.0" encoding="utf-8"?>
 <p1510:revInfo xmlns:a="http://schemas.openxmlformats.org/drawingml/2006/main" xmlns:r="http://schemas.openxmlformats.org/officeDocument/2006/relationships" xmlns:p1510="http://schemas.microsoft.com/office/powerpoint/2015/10/main">
   <p1510:revLst>
-    <p1510:client id="{31E71F23-3A7C-407B-A717-622E46A2A0F5}" v="6064" dt="2026-09-19T07:21:40.557"/>
+    <p1510:client id="{31E71F23-3A7C-407B-A717-622E46A2A0F5}" v="6239" dt="2026-09-25T06:27:35.062"/>
   </p1510:revLst>
 </p1510:revInfo>
 </file>
@@ -213,7 +214,7 @@
   <pc:docChgLst>
     <pc:chgData name="Li, Cong" userId="025630f4-267e-4cb3-8cd5-8795177f99f4" providerId="ADAL" clId="{929A2CC8-B112-421C-81E2-D5D63B23E300}"/>
     <pc:docChg chg="undo redo custSel addSld delSld modSld sldOrd">
-      <pc:chgData name="Li, Cong" userId="025630f4-267e-4cb3-8cd5-8795177f99f4" providerId="ADAL" clId="{929A2CC8-B112-421C-81E2-D5D63B23E300}" dt="2026-09-19T07:21:29.148" v="61453" actId="1076"/>
+      <pc:chgData name="Li, Cong" userId="025630f4-267e-4cb3-8cd5-8795177f99f4" providerId="ADAL" clId="{929A2CC8-B112-421C-81E2-D5D63B23E300}" dt="2026-09-25T06:28:00.661" v="61719" actId="1076"/>
       <pc:docMkLst>
         <pc:docMk/>
       </pc:docMkLst>
@@ -245,20 +246,6 @@
         <pc:sldMkLst>
           <pc:docMk/>
           <pc:sldMk cId="0" sldId="353"/>
-        </pc:sldMkLst>
-      </pc:sldChg>
-      <pc:sldChg chg="addSp delSp modSp add del mod delAnim modAnim">
-        <pc:chgData name="Li, Cong" userId="025630f4-267e-4cb3-8cd5-8795177f99f4" providerId="ADAL" clId="{929A2CC8-B112-421C-81E2-D5D63B23E300}" dt="2026-09-19T06:20:33.292" v="59224" actId="47"/>
-        <pc:sldMkLst>
-          <pc:docMk/>
-          <pc:sldMk cId="2696307608" sldId="403"/>
-        </pc:sldMkLst>
-      </pc:sldChg>
-      <pc:sldChg chg="addSp delSp modSp add del mod delAnim modAnim">
-        <pc:chgData name="Li, Cong" userId="025630f4-267e-4cb3-8cd5-8795177f99f4" providerId="ADAL" clId="{929A2CC8-B112-421C-81E2-D5D63B23E300}" dt="2026-09-19T06:20:33.292" v="59224" actId="47"/>
-        <pc:sldMkLst>
-          <pc:docMk/>
-          <pc:sldMk cId="2903079266" sldId="404"/>
         </pc:sldMkLst>
       </pc:sldChg>
       <pc:sldChg chg="addSp delSp modSp mod delAnim modAnim">
@@ -396,13 +383,6 @@
           </ac:cxnSpMkLst>
         </pc:cxnChg>
       </pc:sldChg>
-      <pc:sldChg chg="modSp del mod">
-        <pc:chgData name="Li, Cong" userId="025630f4-267e-4cb3-8cd5-8795177f99f4" providerId="ADAL" clId="{929A2CC8-B112-421C-81E2-D5D63B23E300}" dt="2026-09-19T06:20:33.292" v="59224" actId="47"/>
-        <pc:sldMkLst>
-          <pc:docMk/>
-          <pc:sldMk cId="381378531" sldId="495"/>
-        </pc:sldMkLst>
-      </pc:sldChg>
       <pc:sldChg chg="modSp mod ord">
         <pc:chgData name="Li, Cong" userId="025630f4-267e-4cb3-8cd5-8795177f99f4" providerId="ADAL" clId="{929A2CC8-B112-421C-81E2-D5D63B23E300}" dt="2026-09-13T09:34:43.311" v="53726"/>
         <pc:sldMkLst>
@@ -441,419 +421,6 @@
             <ac:spMk id="16" creationId="{4B323714-A2D2-AD4F-E366-838463488D12}"/>
           </ac:spMkLst>
         </pc:spChg>
-      </pc:sldChg>
-      <pc:sldChg chg="addSp delSp modSp add del mod addAnim delAnim modAnim">
-        <pc:chgData name="Li, Cong" userId="025630f4-267e-4cb3-8cd5-8795177f99f4" providerId="ADAL" clId="{929A2CC8-B112-421C-81E2-D5D63B23E300}" dt="2026-09-19T06:20:33.292" v="59224" actId="47"/>
-        <pc:sldMkLst>
-          <pc:docMk/>
-          <pc:sldMk cId="2596997907" sldId="545"/>
-        </pc:sldMkLst>
-      </pc:sldChg>
-      <pc:sldChg chg="modSp add del mod modAnim">
-        <pc:chgData name="Li, Cong" userId="025630f4-267e-4cb3-8cd5-8795177f99f4" providerId="ADAL" clId="{929A2CC8-B112-421C-81E2-D5D63B23E300}" dt="2026-09-19T06:20:33.292" v="59224" actId="47"/>
-        <pc:sldMkLst>
-          <pc:docMk/>
-          <pc:sldMk cId="875529958" sldId="549"/>
-        </pc:sldMkLst>
-      </pc:sldChg>
-      <pc:sldChg chg="modSp add del mod modAnim">
-        <pc:chgData name="Li, Cong" userId="025630f4-267e-4cb3-8cd5-8795177f99f4" providerId="ADAL" clId="{929A2CC8-B112-421C-81E2-D5D63B23E300}" dt="2026-09-19T06:20:33.292" v="59224" actId="47"/>
-        <pc:sldMkLst>
-          <pc:docMk/>
-          <pc:sldMk cId="1404580520" sldId="550"/>
-        </pc:sldMkLst>
-      </pc:sldChg>
-      <pc:sldChg chg="addSp delSp modSp add del mod delAnim modAnim">
-        <pc:chgData name="Li, Cong" userId="025630f4-267e-4cb3-8cd5-8795177f99f4" providerId="ADAL" clId="{929A2CC8-B112-421C-81E2-D5D63B23E300}" dt="2026-09-19T06:20:33.292" v="59224" actId="47"/>
-        <pc:sldMkLst>
-          <pc:docMk/>
-          <pc:sldMk cId="1513296632" sldId="551"/>
-        </pc:sldMkLst>
-      </pc:sldChg>
-      <pc:sldChg chg="addSp delSp modSp add del mod delAnim modAnim">
-        <pc:chgData name="Li, Cong" userId="025630f4-267e-4cb3-8cd5-8795177f99f4" providerId="ADAL" clId="{929A2CC8-B112-421C-81E2-D5D63B23E300}" dt="2026-09-19T06:20:33.292" v="59224" actId="47"/>
-        <pc:sldMkLst>
-          <pc:docMk/>
-          <pc:sldMk cId="4049514635" sldId="552"/>
-        </pc:sldMkLst>
-      </pc:sldChg>
-      <pc:sldChg chg="modSp add del mod modAnim">
-        <pc:chgData name="Li, Cong" userId="025630f4-267e-4cb3-8cd5-8795177f99f4" providerId="ADAL" clId="{929A2CC8-B112-421C-81E2-D5D63B23E300}" dt="2026-09-19T06:20:33.292" v="59224" actId="47"/>
-        <pc:sldMkLst>
-          <pc:docMk/>
-          <pc:sldMk cId="772952158" sldId="553"/>
-        </pc:sldMkLst>
-      </pc:sldChg>
-      <pc:sldChg chg="modSp add del mod modAnim">
-        <pc:chgData name="Li, Cong" userId="025630f4-267e-4cb3-8cd5-8795177f99f4" providerId="ADAL" clId="{929A2CC8-B112-421C-81E2-D5D63B23E300}" dt="2026-09-19T06:20:33.292" v="59224" actId="47"/>
-        <pc:sldMkLst>
-          <pc:docMk/>
-          <pc:sldMk cId="2556138800" sldId="554"/>
-        </pc:sldMkLst>
-      </pc:sldChg>
-      <pc:sldChg chg="modSp add del mod modAnim">
-        <pc:chgData name="Li, Cong" userId="025630f4-267e-4cb3-8cd5-8795177f99f4" providerId="ADAL" clId="{929A2CC8-B112-421C-81E2-D5D63B23E300}" dt="2026-09-19T06:20:33.292" v="59224" actId="47"/>
-        <pc:sldMkLst>
-          <pc:docMk/>
-          <pc:sldMk cId="3788633529" sldId="555"/>
-        </pc:sldMkLst>
-      </pc:sldChg>
-      <pc:sldChg chg="addSp delSp modSp add del mod delAnim modAnim">
-        <pc:chgData name="Li, Cong" userId="025630f4-267e-4cb3-8cd5-8795177f99f4" providerId="ADAL" clId="{929A2CC8-B112-421C-81E2-D5D63B23E300}" dt="2026-09-19T06:20:33.292" v="59224" actId="47"/>
-        <pc:sldMkLst>
-          <pc:docMk/>
-          <pc:sldMk cId="3254537065" sldId="556"/>
-        </pc:sldMkLst>
-      </pc:sldChg>
-      <pc:sldChg chg="delSp modSp add del mod delAnim modAnim">
-        <pc:chgData name="Li, Cong" userId="025630f4-267e-4cb3-8cd5-8795177f99f4" providerId="ADAL" clId="{929A2CC8-B112-421C-81E2-D5D63B23E300}" dt="2026-09-19T06:20:33.292" v="59224" actId="47"/>
-        <pc:sldMkLst>
-          <pc:docMk/>
-          <pc:sldMk cId="3497468584" sldId="557"/>
-        </pc:sldMkLst>
-      </pc:sldChg>
-      <pc:sldChg chg="addSp delSp modSp add del mod delAnim modAnim">
-        <pc:chgData name="Li, Cong" userId="025630f4-267e-4cb3-8cd5-8795177f99f4" providerId="ADAL" clId="{929A2CC8-B112-421C-81E2-D5D63B23E300}" dt="2026-09-19T06:20:33.292" v="59224" actId="47"/>
-        <pc:sldMkLst>
-          <pc:docMk/>
-          <pc:sldMk cId="2049009721" sldId="558"/>
-        </pc:sldMkLst>
-      </pc:sldChg>
-      <pc:sldChg chg="modSp add del modAnim">
-        <pc:chgData name="Li, Cong" userId="025630f4-267e-4cb3-8cd5-8795177f99f4" providerId="ADAL" clId="{929A2CC8-B112-421C-81E2-D5D63B23E300}" dt="2026-09-19T06:20:33.292" v="59224" actId="47"/>
-        <pc:sldMkLst>
-          <pc:docMk/>
-          <pc:sldMk cId="789365787" sldId="559"/>
-        </pc:sldMkLst>
-      </pc:sldChg>
-      <pc:sldChg chg="modSp add del mod modAnim">
-        <pc:chgData name="Li, Cong" userId="025630f4-267e-4cb3-8cd5-8795177f99f4" providerId="ADAL" clId="{929A2CC8-B112-421C-81E2-D5D63B23E300}" dt="2026-09-19T06:20:33.292" v="59224" actId="47"/>
-        <pc:sldMkLst>
-          <pc:docMk/>
-          <pc:sldMk cId="296140762" sldId="560"/>
-        </pc:sldMkLst>
-      </pc:sldChg>
-      <pc:sldChg chg="modSp add del mod">
-        <pc:chgData name="Li, Cong" userId="025630f4-267e-4cb3-8cd5-8795177f99f4" providerId="ADAL" clId="{929A2CC8-B112-421C-81E2-D5D63B23E300}" dt="2026-09-19T06:20:33.292" v="59224" actId="47"/>
-        <pc:sldMkLst>
-          <pc:docMk/>
-          <pc:sldMk cId="3798767540" sldId="561"/>
-        </pc:sldMkLst>
-      </pc:sldChg>
-      <pc:sldChg chg="modSp add del mod">
-        <pc:chgData name="Li, Cong" userId="025630f4-267e-4cb3-8cd5-8795177f99f4" providerId="ADAL" clId="{929A2CC8-B112-421C-81E2-D5D63B23E300}" dt="2026-09-19T06:20:33.292" v="59224" actId="47"/>
-        <pc:sldMkLst>
-          <pc:docMk/>
-          <pc:sldMk cId="361834361" sldId="562"/>
-        </pc:sldMkLst>
-      </pc:sldChg>
-      <pc:sldChg chg="modSp add del mod ord modAnim">
-        <pc:chgData name="Li, Cong" userId="025630f4-267e-4cb3-8cd5-8795177f99f4" providerId="ADAL" clId="{929A2CC8-B112-421C-81E2-D5D63B23E300}" dt="2026-09-19T06:20:33.292" v="59224" actId="47"/>
-        <pc:sldMkLst>
-          <pc:docMk/>
-          <pc:sldMk cId="1616448376" sldId="563"/>
-        </pc:sldMkLst>
-      </pc:sldChg>
-      <pc:sldChg chg="modSp add del mod modAnim">
-        <pc:chgData name="Li, Cong" userId="025630f4-267e-4cb3-8cd5-8795177f99f4" providerId="ADAL" clId="{929A2CC8-B112-421C-81E2-D5D63B23E300}" dt="2026-09-19T06:20:33.292" v="59224" actId="47"/>
-        <pc:sldMkLst>
-          <pc:docMk/>
-          <pc:sldMk cId="1460297977" sldId="564"/>
-        </pc:sldMkLst>
-      </pc:sldChg>
-      <pc:sldChg chg="modSp add del mod modAnim">
-        <pc:chgData name="Li, Cong" userId="025630f4-267e-4cb3-8cd5-8795177f99f4" providerId="ADAL" clId="{929A2CC8-B112-421C-81E2-D5D63B23E300}" dt="2026-09-19T06:20:33.292" v="59224" actId="47"/>
-        <pc:sldMkLst>
-          <pc:docMk/>
-          <pc:sldMk cId="725251953" sldId="565"/>
-        </pc:sldMkLst>
-      </pc:sldChg>
-      <pc:sldChg chg="modSp add del mod modAnim">
-        <pc:chgData name="Li, Cong" userId="025630f4-267e-4cb3-8cd5-8795177f99f4" providerId="ADAL" clId="{929A2CC8-B112-421C-81E2-D5D63B23E300}" dt="2026-09-19T06:20:33.292" v="59224" actId="47"/>
-        <pc:sldMkLst>
-          <pc:docMk/>
-          <pc:sldMk cId="262791717" sldId="566"/>
-        </pc:sldMkLst>
-      </pc:sldChg>
-      <pc:sldChg chg="addSp delSp modSp add del mod delAnim modAnim">
-        <pc:chgData name="Li, Cong" userId="025630f4-267e-4cb3-8cd5-8795177f99f4" providerId="ADAL" clId="{929A2CC8-B112-421C-81E2-D5D63B23E300}" dt="2026-09-19T06:20:33.292" v="59224" actId="47"/>
-        <pc:sldMkLst>
-          <pc:docMk/>
-          <pc:sldMk cId="1360670293" sldId="567"/>
-        </pc:sldMkLst>
-      </pc:sldChg>
-      <pc:sldChg chg="addSp delSp modSp add del mod addAnim delAnim modAnim">
-        <pc:chgData name="Li, Cong" userId="025630f4-267e-4cb3-8cd5-8795177f99f4" providerId="ADAL" clId="{929A2CC8-B112-421C-81E2-D5D63B23E300}" dt="2026-09-19T06:20:33.292" v="59224" actId="47"/>
-        <pc:sldMkLst>
-          <pc:docMk/>
-          <pc:sldMk cId="765378416" sldId="568"/>
-        </pc:sldMkLst>
-      </pc:sldChg>
-      <pc:sldChg chg="addSp delSp modSp add del mod addAnim delAnim modAnim">
-        <pc:chgData name="Li, Cong" userId="025630f4-267e-4cb3-8cd5-8795177f99f4" providerId="ADAL" clId="{929A2CC8-B112-421C-81E2-D5D63B23E300}" dt="2026-09-19T06:20:33.292" v="59224" actId="47"/>
-        <pc:sldMkLst>
-          <pc:docMk/>
-          <pc:sldMk cId="4104881251" sldId="569"/>
-        </pc:sldMkLst>
-      </pc:sldChg>
-      <pc:sldChg chg="delSp modSp add del mod delAnim modAnim">
-        <pc:chgData name="Li, Cong" userId="025630f4-267e-4cb3-8cd5-8795177f99f4" providerId="ADAL" clId="{929A2CC8-B112-421C-81E2-D5D63B23E300}" dt="2026-09-19T06:20:33.292" v="59224" actId="47"/>
-        <pc:sldMkLst>
-          <pc:docMk/>
-          <pc:sldMk cId="574952655" sldId="570"/>
-        </pc:sldMkLst>
-      </pc:sldChg>
-      <pc:sldChg chg="addSp delSp modSp add del mod modAnim">
-        <pc:chgData name="Li, Cong" userId="025630f4-267e-4cb3-8cd5-8795177f99f4" providerId="ADAL" clId="{929A2CC8-B112-421C-81E2-D5D63B23E300}" dt="2026-09-19T06:20:33.292" v="59224" actId="47"/>
-        <pc:sldMkLst>
-          <pc:docMk/>
-          <pc:sldMk cId="684406500" sldId="571"/>
-        </pc:sldMkLst>
-      </pc:sldChg>
-      <pc:sldChg chg="modSp add del mod modAnim">
-        <pc:chgData name="Li, Cong" userId="025630f4-267e-4cb3-8cd5-8795177f99f4" providerId="ADAL" clId="{929A2CC8-B112-421C-81E2-D5D63B23E300}" dt="2026-09-19T06:20:33.292" v="59224" actId="47"/>
-        <pc:sldMkLst>
-          <pc:docMk/>
-          <pc:sldMk cId="3610713191" sldId="572"/>
-        </pc:sldMkLst>
-      </pc:sldChg>
-      <pc:sldChg chg="modSp add del mod modAnim">
-        <pc:chgData name="Li, Cong" userId="025630f4-267e-4cb3-8cd5-8795177f99f4" providerId="ADAL" clId="{929A2CC8-B112-421C-81E2-D5D63B23E300}" dt="2026-09-19T06:20:33.292" v="59224" actId="47"/>
-        <pc:sldMkLst>
-          <pc:docMk/>
-          <pc:sldMk cId="318296014" sldId="573"/>
-        </pc:sldMkLst>
-      </pc:sldChg>
-      <pc:sldChg chg="addSp delSp modSp add del mod delAnim modAnim">
-        <pc:chgData name="Li, Cong" userId="025630f4-267e-4cb3-8cd5-8795177f99f4" providerId="ADAL" clId="{929A2CC8-B112-421C-81E2-D5D63B23E300}" dt="2026-09-19T06:20:33.292" v="59224" actId="47"/>
-        <pc:sldMkLst>
-          <pc:docMk/>
-          <pc:sldMk cId="939220885" sldId="574"/>
-        </pc:sldMkLst>
-      </pc:sldChg>
-      <pc:sldChg chg="modSp add del mod modAnim">
-        <pc:chgData name="Li, Cong" userId="025630f4-267e-4cb3-8cd5-8795177f99f4" providerId="ADAL" clId="{929A2CC8-B112-421C-81E2-D5D63B23E300}" dt="2026-09-19T06:20:33.292" v="59224" actId="47"/>
-        <pc:sldMkLst>
-          <pc:docMk/>
-          <pc:sldMk cId="3064806891" sldId="575"/>
-        </pc:sldMkLst>
-      </pc:sldChg>
-      <pc:sldChg chg="addSp modSp add del mod modAnim">
-        <pc:chgData name="Li, Cong" userId="025630f4-267e-4cb3-8cd5-8795177f99f4" providerId="ADAL" clId="{929A2CC8-B112-421C-81E2-D5D63B23E300}" dt="2026-09-19T06:20:33.292" v="59224" actId="47"/>
-        <pc:sldMkLst>
-          <pc:docMk/>
-          <pc:sldMk cId="149371972" sldId="576"/>
-        </pc:sldMkLst>
-      </pc:sldChg>
-      <pc:sldChg chg="addSp delSp modSp add del mod modAnim">
-        <pc:chgData name="Li, Cong" userId="025630f4-267e-4cb3-8cd5-8795177f99f4" providerId="ADAL" clId="{929A2CC8-B112-421C-81E2-D5D63B23E300}" dt="2026-09-19T06:20:33.292" v="59224" actId="47"/>
-        <pc:sldMkLst>
-          <pc:docMk/>
-          <pc:sldMk cId="618587630" sldId="577"/>
-        </pc:sldMkLst>
-      </pc:sldChg>
-      <pc:sldChg chg="modSp add del mod">
-        <pc:chgData name="Li, Cong" userId="025630f4-267e-4cb3-8cd5-8795177f99f4" providerId="ADAL" clId="{929A2CC8-B112-421C-81E2-D5D63B23E300}" dt="2026-09-19T06:20:33.292" v="59224" actId="47"/>
-        <pc:sldMkLst>
-          <pc:docMk/>
-          <pc:sldMk cId="1910721519" sldId="578"/>
-        </pc:sldMkLst>
-      </pc:sldChg>
-      <pc:sldChg chg="modSp add del mod">
-        <pc:chgData name="Li, Cong" userId="025630f4-267e-4cb3-8cd5-8795177f99f4" providerId="ADAL" clId="{929A2CC8-B112-421C-81E2-D5D63B23E300}" dt="2026-09-19T06:20:33.292" v="59224" actId="47"/>
-        <pc:sldMkLst>
-          <pc:docMk/>
-          <pc:sldMk cId="2065498570" sldId="579"/>
-        </pc:sldMkLst>
-      </pc:sldChg>
-      <pc:sldChg chg="modSp add del mod">
-        <pc:chgData name="Li, Cong" userId="025630f4-267e-4cb3-8cd5-8795177f99f4" providerId="ADAL" clId="{929A2CC8-B112-421C-81E2-D5D63B23E300}" dt="2026-09-19T06:20:33.292" v="59224" actId="47"/>
-        <pc:sldMkLst>
-          <pc:docMk/>
-          <pc:sldMk cId="1704827406" sldId="580"/>
-        </pc:sldMkLst>
-      </pc:sldChg>
-      <pc:sldChg chg="modSp add del mod">
-        <pc:chgData name="Li, Cong" userId="025630f4-267e-4cb3-8cd5-8795177f99f4" providerId="ADAL" clId="{929A2CC8-B112-421C-81E2-D5D63B23E300}" dt="2026-09-19T06:20:33.292" v="59224" actId="47"/>
-        <pc:sldMkLst>
-          <pc:docMk/>
-          <pc:sldMk cId="3079135240" sldId="581"/>
-        </pc:sldMkLst>
-      </pc:sldChg>
-      <pc:sldChg chg="addSp modSp add del mod">
-        <pc:chgData name="Li, Cong" userId="025630f4-267e-4cb3-8cd5-8795177f99f4" providerId="ADAL" clId="{929A2CC8-B112-421C-81E2-D5D63B23E300}" dt="2026-09-19T06:20:33.292" v="59224" actId="47"/>
-        <pc:sldMkLst>
-          <pc:docMk/>
-          <pc:sldMk cId="1208437852" sldId="582"/>
-        </pc:sldMkLst>
-      </pc:sldChg>
-      <pc:sldChg chg="addSp delSp modSp add del mod delAnim modAnim">
-        <pc:chgData name="Li, Cong" userId="025630f4-267e-4cb3-8cd5-8795177f99f4" providerId="ADAL" clId="{929A2CC8-B112-421C-81E2-D5D63B23E300}" dt="2026-09-19T06:20:33.292" v="59224" actId="47"/>
-        <pc:sldMkLst>
-          <pc:docMk/>
-          <pc:sldMk cId="3753803810" sldId="583"/>
-        </pc:sldMkLst>
-      </pc:sldChg>
-      <pc:sldChg chg="addSp delSp modSp add del mod delAnim modAnim">
-        <pc:chgData name="Li, Cong" userId="025630f4-267e-4cb3-8cd5-8795177f99f4" providerId="ADAL" clId="{929A2CC8-B112-421C-81E2-D5D63B23E300}" dt="2026-09-19T06:20:33.292" v="59224" actId="47"/>
-        <pc:sldMkLst>
-          <pc:docMk/>
-          <pc:sldMk cId="2500887379" sldId="584"/>
-        </pc:sldMkLst>
-      </pc:sldChg>
-      <pc:sldChg chg="addSp delSp modSp add del mod modAnim">
-        <pc:chgData name="Li, Cong" userId="025630f4-267e-4cb3-8cd5-8795177f99f4" providerId="ADAL" clId="{929A2CC8-B112-421C-81E2-D5D63B23E300}" dt="2026-09-19T06:20:33.292" v="59224" actId="47"/>
-        <pc:sldMkLst>
-          <pc:docMk/>
-          <pc:sldMk cId="2528163013" sldId="585"/>
-        </pc:sldMkLst>
-      </pc:sldChg>
-      <pc:sldChg chg="addSp delSp modSp add del mod delAnim modAnim">
-        <pc:chgData name="Li, Cong" userId="025630f4-267e-4cb3-8cd5-8795177f99f4" providerId="ADAL" clId="{929A2CC8-B112-421C-81E2-D5D63B23E300}" dt="2026-09-19T06:20:33.292" v="59224" actId="47"/>
-        <pc:sldMkLst>
-          <pc:docMk/>
-          <pc:sldMk cId="1788352540" sldId="586"/>
-        </pc:sldMkLst>
-      </pc:sldChg>
-      <pc:sldChg chg="addSp modSp add del mod modAnim">
-        <pc:chgData name="Li, Cong" userId="025630f4-267e-4cb3-8cd5-8795177f99f4" providerId="ADAL" clId="{929A2CC8-B112-421C-81E2-D5D63B23E300}" dt="2026-09-19T06:20:33.292" v="59224" actId="47"/>
-        <pc:sldMkLst>
-          <pc:docMk/>
-          <pc:sldMk cId="2841467001" sldId="587"/>
-        </pc:sldMkLst>
-      </pc:sldChg>
-      <pc:sldChg chg="modSp add del mod">
-        <pc:chgData name="Li, Cong" userId="025630f4-267e-4cb3-8cd5-8795177f99f4" providerId="ADAL" clId="{929A2CC8-B112-421C-81E2-D5D63B23E300}" dt="2026-09-19T06:20:33.292" v="59224" actId="47"/>
-        <pc:sldMkLst>
-          <pc:docMk/>
-          <pc:sldMk cId="227514560" sldId="588"/>
-        </pc:sldMkLst>
-      </pc:sldChg>
-      <pc:sldChg chg="addSp delSp modSp add del mod delAnim modAnim">
-        <pc:chgData name="Li, Cong" userId="025630f4-267e-4cb3-8cd5-8795177f99f4" providerId="ADAL" clId="{929A2CC8-B112-421C-81E2-D5D63B23E300}" dt="2026-09-19T06:20:33.292" v="59224" actId="47"/>
-        <pc:sldMkLst>
-          <pc:docMk/>
-          <pc:sldMk cId="616582766" sldId="589"/>
-        </pc:sldMkLst>
-      </pc:sldChg>
-      <pc:sldChg chg="addSp delSp modSp add del mod delAnim modAnim">
-        <pc:chgData name="Li, Cong" userId="025630f4-267e-4cb3-8cd5-8795177f99f4" providerId="ADAL" clId="{929A2CC8-B112-421C-81E2-D5D63B23E300}" dt="2026-09-19T06:20:33.292" v="59224" actId="47"/>
-        <pc:sldMkLst>
-          <pc:docMk/>
-          <pc:sldMk cId="206824336" sldId="590"/>
-        </pc:sldMkLst>
-      </pc:sldChg>
-      <pc:sldChg chg="addSp delSp modSp add del mod modAnim">
-        <pc:chgData name="Li, Cong" userId="025630f4-267e-4cb3-8cd5-8795177f99f4" providerId="ADAL" clId="{929A2CC8-B112-421C-81E2-D5D63B23E300}" dt="2026-09-19T06:20:33.292" v="59224" actId="47"/>
-        <pc:sldMkLst>
-          <pc:docMk/>
-          <pc:sldMk cId="386765367" sldId="591"/>
-        </pc:sldMkLst>
-      </pc:sldChg>
-      <pc:sldChg chg="addSp delSp modSp add del mod delAnim modAnim">
-        <pc:chgData name="Li, Cong" userId="025630f4-267e-4cb3-8cd5-8795177f99f4" providerId="ADAL" clId="{929A2CC8-B112-421C-81E2-D5D63B23E300}" dt="2026-09-19T06:20:33.292" v="59224" actId="47"/>
-        <pc:sldMkLst>
-          <pc:docMk/>
-          <pc:sldMk cId="2712220374" sldId="592"/>
-        </pc:sldMkLst>
-      </pc:sldChg>
-      <pc:sldChg chg="addSp delSp modSp add del mod modAnim">
-        <pc:chgData name="Li, Cong" userId="025630f4-267e-4cb3-8cd5-8795177f99f4" providerId="ADAL" clId="{929A2CC8-B112-421C-81E2-D5D63B23E300}" dt="2026-09-19T06:20:33.292" v="59224" actId="47"/>
-        <pc:sldMkLst>
-          <pc:docMk/>
-          <pc:sldMk cId="1234627996" sldId="594"/>
-        </pc:sldMkLst>
-      </pc:sldChg>
-      <pc:sldChg chg="addSp delSp modSp add del mod modAnim">
-        <pc:chgData name="Li, Cong" userId="025630f4-267e-4cb3-8cd5-8795177f99f4" providerId="ADAL" clId="{929A2CC8-B112-421C-81E2-D5D63B23E300}" dt="2026-09-19T06:20:33.292" v="59224" actId="47"/>
-        <pc:sldMkLst>
-          <pc:docMk/>
-          <pc:sldMk cId="2231171154" sldId="595"/>
-        </pc:sldMkLst>
-      </pc:sldChg>
-      <pc:sldChg chg="addSp delSp modSp add del mod delAnim modAnim">
-        <pc:chgData name="Li, Cong" userId="025630f4-267e-4cb3-8cd5-8795177f99f4" providerId="ADAL" clId="{929A2CC8-B112-421C-81E2-D5D63B23E300}" dt="2026-09-19T06:20:33.292" v="59224" actId="47"/>
-        <pc:sldMkLst>
-          <pc:docMk/>
-          <pc:sldMk cId="827556008" sldId="596"/>
-        </pc:sldMkLst>
-      </pc:sldChg>
-      <pc:sldChg chg="addSp delSp modSp add del mod delAnim modAnim">
-        <pc:chgData name="Li, Cong" userId="025630f4-267e-4cb3-8cd5-8795177f99f4" providerId="ADAL" clId="{929A2CC8-B112-421C-81E2-D5D63B23E300}" dt="2026-09-19T06:20:33.292" v="59224" actId="47"/>
-        <pc:sldMkLst>
-          <pc:docMk/>
-          <pc:sldMk cId="117473122" sldId="597"/>
-        </pc:sldMkLst>
-      </pc:sldChg>
-      <pc:sldChg chg="delSp add del mod delAnim modAnim">
-        <pc:chgData name="Li, Cong" userId="025630f4-267e-4cb3-8cd5-8795177f99f4" providerId="ADAL" clId="{929A2CC8-B112-421C-81E2-D5D63B23E300}" dt="2026-09-19T06:20:33.292" v="59224" actId="47"/>
-        <pc:sldMkLst>
-          <pc:docMk/>
-          <pc:sldMk cId="2908738087" sldId="598"/>
-        </pc:sldMkLst>
-      </pc:sldChg>
-      <pc:sldChg chg="addSp delSp modSp add del mod delAnim modAnim">
-        <pc:chgData name="Li, Cong" userId="025630f4-267e-4cb3-8cd5-8795177f99f4" providerId="ADAL" clId="{929A2CC8-B112-421C-81E2-D5D63B23E300}" dt="2026-09-19T06:20:33.292" v="59224" actId="47"/>
-        <pc:sldMkLst>
-          <pc:docMk/>
-          <pc:sldMk cId="2438670737" sldId="599"/>
-        </pc:sldMkLst>
-      </pc:sldChg>
-      <pc:sldChg chg="modSp add del mod">
-        <pc:chgData name="Li, Cong" userId="025630f4-267e-4cb3-8cd5-8795177f99f4" providerId="ADAL" clId="{929A2CC8-B112-421C-81E2-D5D63B23E300}" dt="2026-09-19T06:20:33.292" v="59224" actId="47"/>
-        <pc:sldMkLst>
-          <pc:docMk/>
-          <pc:sldMk cId="2004461925" sldId="600"/>
-        </pc:sldMkLst>
-      </pc:sldChg>
-      <pc:sldChg chg="modSp add del mod">
-        <pc:chgData name="Li, Cong" userId="025630f4-267e-4cb3-8cd5-8795177f99f4" providerId="ADAL" clId="{929A2CC8-B112-421C-81E2-D5D63B23E300}" dt="2026-09-19T06:20:33.292" v="59224" actId="47"/>
-        <pc:sldMkLst>
-          <pc:docMk/>
-          <pc:sldMk cId="1830521581" sldId="601"/>
-        </pc:sldMkLst>
-      </pc:sldChg>
-      <pc:sldChg chg="addSp delSp modSp add del mod delAnim modAnim">
-        <pc:chgData name="Li, Cong" userId="025630f4-267e-4cb3-8cd5-8795177f99f4" providerId="ADAL" clId="{929A2CC8-B112-421C-81E2-D5D63B23E300}" dt="2026-09-19T06:20:33.292" v="59224" actId="47"/>
-        <pc:sldMkLst>
-          <pc:docMk/>
-          <pc:sldMk cId="3519368684" sldId="602"/>
-        </pc:sldMkLst>
-      </pc:sldChg>
-      <pc:sldChg chg="modSp add del mod modAnim">
-        <pc:chgData name="Li, Cong" userId="025630f4-267e-4cb3-8cd5-8795177f99f4" providerId="ADAL" clId="{929A2CC8-B112-421C-81E2-D5D63B23E300}" dt="2026-09-19T06:20:33.292" v="59224" actId="47"/>
-        <pc:sldMkLst>
-          <pc:docMk/>
-          <pc:sldMk cId="3366711331" sldId="603"/>
-        </pc:sldMkLst>
-      </pc:sldChg>
-      <pc:sldChg chg="modSp add del mod modAnim">
-        <pc:chgData name="Li, Cong" userId="025630f4-267e-4cb3-8cd5-8795177f99f4" providerId="ADAL" clId="{929A2CC8-B112-421C-81E2-D5D63B23E300}" dt="2026-09-19T06:20:33.292" v="59224" actId="47"/>
-        <pc:sldMkLst>
-          <pc:docMk/>
-          <pc:sldMk cId="3336791036" sldId="604"/>
-        </pc:sldMkLst>
-      </pc:sldChg>
-      <pc:sldChg chg="modSp add del mod modAnim">
-        <pc:chgData name="Li, Cong" userId="025630f4-267e-4cb3-8cd5-8795177f99f4" providerId="ADAL" clId="{929A2CC8-B112-421C-81E2-D5D63B23E300}" dt="2026-09-19T06:20:33.292" v="59224" actId="47"/>
-        <pc:sldMkLst>
-          <pc:docMk/>
-          <pc:sldMk cId="574682032" sldId="605"/>
-        </pc:sldMkLst>
-      </pc:sldChg>
-      <pc:sldChg chg="addSp delSp modSp add del mod delAnim modAnim">
-        <pc:chgData name="Li, Cong" userId="025630f4-267e-4cb3-8cd5-8795177f99f4" providerId="ADAL" clId="{929A2CC8-B112-421C-81E2-D5D63B23E300}" dt="2026-09-19T06:20:33.292" v="59224" actId="47"/>
-        <pc:sldMkLst>
-          <pc:docMk/>
-          <pc:sldMk cId="464186355" sldId="606"/>
-        </pc:sldMkLst>
-      </pc:sldChg>
-      <pc:sldChg chg="addSp modSp add del mod modAnim">
-        <pc:chgData name="Li, Cong" userId="025630f4-267e-4cb3-8cd5-8795177f99f4" providerId="ADAL" clId="{929A2CC8-B112-421C-81E2-D5D63B23E300}" dt="2026-09-19T06:20:33.292" v="59224" actId="47"/>
-        <pc:sldMkLst>
-          <pc:docMk/>
-          <pc:sldMk cId="425359424" sldId="607"/>
-        </pc:sldMkLst>
       </pc:sldChg>
       <pc:sldChg chg="addSp delSp modSp add mod delAnim modAnim">
         <pc:chgData name="Li, Cong" userId="025630f4-267e-4cb3-8cd5-8795177f99f4" providerId="ADAL" clId="{929A2CC8-B112-421C-81E2-D5D63B23E300}" dt="2026-09-19T07:18:44.869" v="61366" actId="1076"/>
@@ -909,83 +476,6 @@
             <ac:spMk id="13" creationId="{66468BA3-10C8-7207-F425-7DC1EF4E0F8A}"/>
           </ac:spMkLst>
         </pc:spChg>
-      </pc:sldChg>
-      <pc:sldChg chg="addSp delSp modSp add del mod delAnim modAnim">
-        <pc:chgData name="Li, Cong" userId="025630f4-267e-4cb3-8cd5-8795177f99f4" providerId="ADAL" clId="{929A2CC8-B112-421C-81E2-D5D63B23E300}" dt="2026-09-19T06:20:33.292" v="59224" actId="47"/>
-        <pc:sldMkLst>
-          <pc:docMk/>
-          <pc:sldMk cId="1413003058" sldId="609"/>
-        </pc:sldMkLst>
-      </pc:sldChg>
-      <pc:sldChg chg="addSp delSp modSp add del mod delAnim modAnim">
-        <pc:chgData name="Li, Cong" userId="025630f4-267e-4cb3-8cd5-8795177f99f4" providerId="ADAL" clId="{929A2CC8-B112-421C-81E2-D5D63B23E300}" dt="2026-09-19T06:20:33.292" v="59224" actId="47"/>
-        <pc:sldMkLst>
-          <pc:docMk/>
-          <pc:sldMk cId="605721647" sldId="610"/>
-        </pc:sldMkLst>
-      </pc:sldChg>
-      <pc:sldChg chg="modSp add del mod modAnim">
-        <pc:chgData name="Li, Cong" userId="025630f4-267e-4cb3-8cd5-8795177f99f4" providerId="ADAL" clId="{929A2CC8-B112-421C-81E2-D5D63B23E300}" dt="2026-09-19T06:20:33.292" v="59224" actId="47"/>
-        <pc:sldMkLst>
-          <pc:docMk/>
-          <pc:sldMk cId="3307187633" sldId="611"/>
-        </pc:sldMkLst>
-      </pc:sldChg>
-      <pc:sldChg chg="addSp delSp modSp add del mod modAnim">
-        <pc:chgData name="Li, Cong" userId="025630f4-267e-4cb3-8cd5-8795177f99f4" providerId="ADAL" clId="{929A2CC8-B112-421C-81E2-D5D63B23E300}" dt="2026-09-19T06:20:33.292" v="59224" actId="47"/>
-        <pc:sldMkLst>
-          <pc:docMk/>
-          <pc:sldMk cId="323397779" sldId="612"/>
-        </pc:sldMkLst>
-      </pc:sldChg>
-      <pc:sldChg chg="addSp delSp modSp add del mod modAnim">
-        <pc:chgData name="Li, Cong" userId="025630f4-267e-4cb3-8cd5-8795177f99f4" providerId="ADAL" clId="{929A2CC8-B112-421C-81E2-D5D63B23E300}" dt="2026-09-19T06:20:33.292" v="59224" actId="47"/>
-        <pc:sldMkLst>
-          <pc:docMk/>
-          <pc:sldMk cId="2936896630" sldId="613"/>
-        </pc:sldMkLst>
-      </pc:sldChg>
-      <pc:sldChg chg="addSp modSp add del mod modAnim">
-        <pc:chgData name="Li, Cong" userId="025630f4-267e-4cb3-8cd5-8795177f99f4" providerId="ADAL" clId="{929A2CC8-B112-421C-81E2-D5D63B23E300}" dt="2026-09-19T06:20:33.292" v="59224" actId="47"/>
-        <pc:sldMkLst>
-          <pc:docMk/>
-          <pc:sldMk cId="4216651519" sldId="614"/>
-        </pc:sldMkLst>
-      </pc:sldChg>
-      <pc:sldChg chg="addSp modSp add del mod modAnim">
-        <pc:chgData name="Li, Cong" userId="025630f4-267e-4cb3-8cd5-8795177f99f4" providerId="ADAL" clId="{929A2CC8-B112-421C-81E2-D5D63B23E300}" dt="2026-09-19T06:20:33.292" v="59224" actId="47"/>
-        <pc:sldMkLst>
-          <pc:docMk/>
-          <pc:sldMk cId="3085789375" sldId="615"/>
-        </pc:sldMkLst>
-      </pc:sldChg>
-      <pc:sldChg chg="addSp delSp modSp add del mod delAnim modAnim">
-        <pc:chgData name="Li, Cong" userId="025630f4-267e-4cb3-8cd5-8795177f99f4" providerId="ADAL" clId="{929A2CC8-B112-421C-81E2-D5D63B23E300}" dt="2026-09-19T06:20:33.292" v="59224" actId="47"/>
-        <pc:sldMkLst>
-          <pc:docMk/>
-          <pc:sldMk cId="3157238870" sldId="616"/>
-        </pc:sldMkLst>
-      </pc:sldChg>
-      <pc:sldChg chg="modSp add del modAnim">
-        <pc:chgData name="Li, Cong" userId="025630f4-267e-4cb3-8cd5-8795177f99f4" providerId="ADAL" clId="{929A2CC8-B112-421C-81E2-D5D63B23E300}" dt="2026-09-19T06:20:33.292" v="59224" actId="47"/>
-        <pc:sldMkLst>
-          <pc:docMk/>
-          <pc:sldMk cId="3946308661" sldId="617"/>
-        </pc:sldMkLst>
-      </pc:sldChg>
-      <pc:sldChg chg="modSp add del mod addAnim delAnim modAnim">
-        <pc:chgData name="Li, Cong" userId="025630f4-267e-4cb3-8cd5-8795177f99f4" providerId="ADAL" clId="{929A2CC8-B112-421C-81E2-D5D63B23E300}" dt="2026-09-19T06:20:33.292" v="59224" actId="47"/>
-        <pc:sldMkLst>
-          <pc:docMk/>
-          <pc:sldMk cId="340559113" sldId="618"/>
-        </pc:sldMkLst>
-      </pc:sldChg>
-      <pc:sldChg chg="modSp add del mod modAnim">
-        <pc:chgData name="Li, Cong" userId="025630f4-267e-4cb3-8cd5-8795177f99f4" providerId="ADAL" clId="{929A2CC8-B112-421C-81E2-D5D63B23E300}" dt="2026-09-19T06:20:33.292" v="59224" actId="47"/>
-        <pc:sldMkLst>
-          <pc:docMk/>
-          <pc:sldMk cId="774211148" sldId="619"/>
-        </pc:sldMkLst>
       </pc:sldChg>
       <pc:sldChg chg="modSp add mod modAnim">
         <pc:chgData name="Li, Cong" userId="025630f4-267e-4cb3-8cd5-8795177f99f4" providerId="ADAL" clId="{929A2CC8-B112-421C-81E2-D5D63B23E300}" dt="2026-09-13T09:35:38.396" v="53802"/>
@@ -1103,14 +593,6 @@
             <ac:spMk id="5" creationId="{06927470-85DA-5FD1-6A79-58FDA4D1F235}"/>
           </ac:spMkLst>
         </pc:spChg>
-        <pc:spChg chg="add mod">
-          <ac:chgData name="Li, Cong" userId="025630f4-267e-4cb3-8cd5-8795177f99f4" providerId="ADAL" clId="{929A2CC8-B112-421C-81E2-D5D63B23E300}" dt="2026-09-19T00:20:56.848" v="54326" actId="20577"/>
-          <ac:spMkLst>
-            <pc:docMk/>
-            <pc:sldMk cId="3413070866" sldId="622"/>
-            <ac:spMk id="6" creationId="{747DD22F-C475-7C57-7AAD-93460F4C5272}"/>
-          </ac:spMkLst>
-        </pc:spChg>
         <pc:spChg chg="mod">
           <ac:chgData name="Li, Cong" userId="025630f4-267e-4cb3-8cd5-8795177f99f4" providerId="ADAL" clId="{929A2CC8-B112-421C-81E2-D5D63B23E300}" dt="2026-09-19T00:37:22.620" v="54397" actId="14100"/>
           <ac:spMkLst>
@@ -1133,38 +615,6 @@
             <pc:docMk/>
             <pc:sldMk cId="3413070866" sldId="622"/>
             <ac:spMk id="9" creationId="{FAE5EDE7-8C8B-FF8A-0777-87C99F2C5E93}"/>
-          </ac:spMkLst>
-        </pc:spChg>
-        <pc:spChg chg="del">
-          <ac:chgData name="Li, Cong" userId="025630f4-267e-4cb3-8cd5-8795177f99f4" providerId="ADAL" clId="{929A2CC8-B112-421C-81E2-D5D63B23E300}" dt="2026-09-19T00:20:16.437" v="54282" actId="478"/>
-          <ac:spMkLst>
-            <pc:docMk/>
-            <pc:sldMk cId="3413070866" sldId="622"/>
-            <ac:spMk id="10" creationId="{6ECD0950-635A-0E08-6696-9150964CEFFE}"/>
-          </ac:spMkLst>
-        </pc:spChg>
-        <pc:spChg chg="del">
-          <ac:chgData name="Li, Cong" userId="025630f4-267e-4cb3-8cd5-8795177f99f4" providerId="ADAL" clId="{929A2CC8-B112-421C-81E2-D5D63B23E300}" dt="2026-09-19T00:37:44.220" v="54403" actId="478"/>
-          <ac:spMkLst>
-            <pc:docMk/>
-            <pc:sldMk cId="3413070866" sldId="622"/>
-            <ac:spMk id="11" creationId="{02BB25D6-452B-4224-EFDB-B8BC8E307A67}"/>
-          </ac:spMkLst>
-        </pc:spChg>
-        <pc:spChg chg="del mod">
-          <ac:chgData name="Li, Cong" userId="025630f4-267e-4cb3-8cd5-8795177f99f4" providerId="ADAL" clId="{929A2CC8-B112-421C-81E2-D5D63B23E300}" dt="2026-09-19T00:37:39.356" v="54400" actId="478"/>
-          <ac:spMkLst>
-            <pc:docMk/>
-            <pc:sldMk cId="3413070866" sldId="622"/>
-            <ac:spMk id="12" creationId="{B5109A74-74F7-ADAF-F208-9C48673FD9E5}"/>
-          </ac:spMkLst>
-        </pc:spChg>
-        <pc:spChg chg="del">
-          <ac:chgData name="Li, Cong" userId="025630f4-267e-4cb3-8cd5-8795177f99f4" providerId="ADAL" clId="{929A2CC8-B112-421C-81E2-D5D63B23E300}" dt="2026-09-19T00:35:29.106" v="54368" actId="478"/>
-          <ac:spMkLst>
-            <pc:docMk/>
-            <pc:sldMk cId="3413070866" sldId="622"/>
-            <ac:spMk id="15" creationId="{A0F3B1AB-7128-19D8-7335-300A21AAF99B}"/>
           </ac:spMkLst>
         </pc:spChg>
         <pc:spChg chg="add mod">
@@ -1199,22 +649,6 @@
             <ac:spMk id="23" creationId="{26F9DC84-3B3D-6DA4-6F02-0FE7A9880FBB}"/>
           </ac:spMkLst>
         </pc:spChg>
-        <pc:cxnChg chg="del mod">
-          <ac:chgData name="Li, Cong" userId="025630f4-267e-4cb3-8cd5-8795177f99f4" providerId="ADAL" clId="{929A2CC8-B112-421C-81E2-D5D63B23E300}" dt="2026-09-19T00:37:41.467" v="54401" actId="478"/>
-          <ac:cxnSpMkLst>
-            <pc:docMk/>
-            <pc:sldMk cId="3413070866" sldId="622"/>
-            <ac:cxnSpMk id="13" creationId="{D2632CEE-1673-690B-D6F5-1996564AA124}"/>
-          </ac:cxnSpMkLst>
-        </pc:cxnChg>
-        <pc:cxnChg chg="del mod">
-          <ac:chgData name="Li, Cong" userId="025630f4-267e-4cb3-8cd5-8795177f99f4" providerId="ADAL" clId="{929A2CC8-B112-421C-81E2-D5D63B23E300}" dt="2026-09-19T00:37:43.213" v="54402" actId="478"/>
-          <ac:cxnSpMkLst>
-            <pc:docMk/>
-            <pc:sldMk cId="3413070866" sldId="622"/>
-            <ac:cxnSpMk id="18" creationId="{DACB37C3-9834-B2B3-52F9-A04218E7C18E}"/>
-          </ac:cxnSpMkLst>
-        </pc:cxnChg>
         <pc:cxnChg chg="add mod">
           <ac:chgData name="Li, Cong" userId="025630f4-267e-4cb3-8cd5-8795177f99f4" providerId="ADAL" clId="{929A2CC8-B112-421C-81E2-D5D63B23E300}" dt="2026-09-19T00:38:44.474" v="54411" actId="1035"/>
           <ac:cxnSpMkLst>
@@ -1246,22 +680,6 @@
           <pc:docMk/>
           <pc:sldMk cId="1832066435" sldId="623"/>
         </pc:sldMkLst>
-        <pc:spChg chg="del">
-          <ac:chgData name="Li, Cong" userId="025630f4-267e-4cb3-8cd5-8795177f99f4" providerId="ADAL" clId="{929A2CC8-B112-421C-81E2-D5D63B23E300}" dt="2026-09-19T00:37:12.561" v="54395" actId="478"/>
-          <ac:spMkLst>
-            <pc:docMk/>
-            <pc:sldMk cId="1832066435" sldId="623"/>
-            <ac:spMk id="3" creationId="{702D217D-E75C-0F28-65B0-3CE6EF76B389}"/>
-          </ac:spMkLst>
-        </pc:spChg>
-        <pc:spChg chg="del">
-          <ac:chgData name="Li, Cong" userId="025630f4-267e-4cb3-8cd5-8795177f99f4" providerId="ADAL" clId="{929A2CC8-B112-421C-81E2-D5D63B23E300}" dt="2026-09-19T00:37:09.884" v="54394" actId="478"/>
-          <ac:spMkLst>
-            <pc:docMk/>
-            <pc:sldMk cId="1832066435" sldId="623"/>
-            <ac:spMk id="8" creationId="{FF3E4820-9B5F-FBA3-2420-B2A4A0140880}"/>
-          </ac:spMkLst>
-        </pc:spChg>
         <pc:spChg chg="add mod">
           <ac:chgData name="Li, Cong" userId="025630f4-267e-4cb3-8cd5-8795177f99f4" providerId="ADAL" clId="{929A2CC8-B112-421C-81E2-D5D63B23E300}" dt="2026-09-19T00:36:28.789" v="54381" actId="1076"/>
           <ac:spMkLst>
@@ -1310,14 +728,6 @@
             <ac:cxnSpMk id="15" creationId="{5F76EEE3-7055-5D15-7219-B7E041555D1F}"/>
           </ac:cxnSpMkLst>
         </pc:cxnChg>
-        <pc:cxnChg chg="del mod">
-          <ac:chgData name="Li, Cong" userId="025630f4-267e-4cb3-8cd5-8795177f99f4" providerId="ADAL" clId="{929A2CC8-B112-421C-81E2-D5D63B23E300}" dt="2026-09-19T00:36:48.011" v="54390" actId="478"/>
-          <ac:cxnSpMkLst>
-            <pc:docMk/>
-            <pc:sldMk cId="1832066435" sldId="623"/>
-            <ac:cxnSpMk id="18" creationId="{8AB9B0D6-9B20-5BC8-ACE2-C0D59B8DA52E}"/>
-          </ac:cxnSpMkLst>
-        </pc:cxnChg>
         <pc:cxnChg chg="add mod">
           <ac:chgData name="Li, Cong" userId="025630f4-267e-4cb3-8cd5-8795177f99f4" providerId="ADAL" clId="{929A2CC8-B112-421C-81E2-D5D63B23E300}" dt="2026-09-19T00:37:07.045" v="54393" actId="1076"/>
           <ac:cxnSpMkLst>
@@ -1349,54 +759,6 @@
             <ac:spMk id="19" creationId="{B229959F-12A4-AD02-8279-2FDBA1A35AE3}"/>
           </ac:spMkLst>
         </pc:spChg>
-        <pc:spChg chg="del">
-          <ac:chgData name="Li, Cong" userId="025630f4-267e-4cb3-8cd5-8795177f99f4" providerId="ADAL" clId="{929A2CC8-B112-421C-81E2-D5D63B23E300}" dt="2026-09-19T00:41:12.454" v="54451" actId="478"/>
-          <ac:spMkLst>
-            <pc:docMk/>
-            <pc:sldMk cId="3374870307" sldId="624"/>
-            <ac:spMk id="20" creationId="{8E1826DE-3580-3B4F-720D-EA1925770565}"/>
-          </ac:spMkLst>
-        </pc:spChg>
-        <pc:spChg chg="del">
-          <ac:chgData name="Li, Cong" userId="025630f4-267e-4cb3-8cd5-8795177f99f4" providerId="ADAL" clId="{929A2CC8-B112-421C-81E2-D5D63B23E300}" dt="2026-09-19T00:41:12.454" v="54451" actId="478"/>
-          <ac:spMkLst>
-            <pc:docMk/>
-            <pc:sldMk cId="3374870307" sldId="624"/>
-            <ac:spMk id="22" creationId="{BDC2ECE1-0260-7F90-543C-B1794EBABBBC}"/>
-          </ac:spMkLst>
-        </pc:spChg>
-        <pc:spChg chg="del">
-          <ac:chgData name="Li, Cong" userId="025630f4-267e-4cb3-8cd5-8795177f99f4" providerId="ADAL" clId="{929A2CC8-B112-421C-81E2-D5D63B23E300}" dt="2026-09-19T00:41:12.454" v="54451" actId="478"/>
-          <ac:spMkLst>
-            <pc:docMk/>
-            <pc:sldMk cId="3374870307" sldId="624"/>
-            <ac:spMk id="23" creationId="{51073840-2E4E-D9DF-35AA-F769E3805902}"/>
-          </ac:spMkLst>
-        </pc:spChg>
-        <pc:cxnChg chg="del mod">
-          <ac:chgData name="Li, Cong" userId="025630f4-267e-4cb3-8cd5-8795177f99f4" providerId="ADAL" clId="{929A2CC8-B112-421C-81E2-D5D63B23E300}" dt="2026-09-19T00:41:12.454" v="54451" actId="478"/>
-          <ac:cxnSpMkLst>
-            <pc:docMk/>
-            <pc:sldMk cId="3374870307" sldId="624"/>
-            <ac:cxnSpMk id="21" creationId="{EE8F36A1-120A-A016-44C2-C6E8573A8526}"/>
-          </ac:cxnSpMkLst>
-        </pc:cxnChg>
-        <pc:cxnChg chg="del mod">
-          <ac:chgData name="Li, Cong" userId="025630f4-267e-4cb3-8cd5-8795177f99f4" providerId="ADAL" clId="{929A2CC8-B112-421C-81E2-D5D63B23E300}" dt="2026-09-19T00:41:12.454" v="54451" actId="478"/>
-          <ac:cxnSpMkLst>
-            <pc:docMk/>
-            <pc:sldMk cId="3374870307" sldId="624"/>
-            <ac:cxnSpMk id="24" creationId="{F2226C1D-C331-23E7-7DDA-AB9C51809F3A}"/>
-          </ac:cxnSpMkLst>
-        </pc:cxnChg>
-        <pc:cxnChg chg="del mod">
-          <ac:chgData name="Li, Cong" userId="025630f4-267e-4cb3-8cd5-8795177f99f4" providerId="ADAL" clId="{929A2CC8-B112-421C-81E2-D5D63B23E300}" dt="2026-09-19T00:41:12.454" v="54451" actId="478"/>
-          <ac:cxnSpMkLst>
-            <pc:docMk/>
-            <pc:sldMk cId="3374870307" sldId="624"/>
-            <ac:cxnSpMk id="25" creationId="{7CD84EF7-E262-310E-B102-153A40EDE7B0}"/>
-          </ac:cxnSpMkLst>
-        </pc:cxnChg>
       </pc:sldChg>
       <pc:sldChg chg="addSp delSp modSp add mod delAnim modAnim">
         <pc:chgData name="Li, Cong" userId="025630f4-267e-4cb3-8cd5-8795177f99f4" providerId="ADAL" clId="{929A2CC8-B112-421C-81E2-D5D63B23E300}" dt="2026-09-19T00:54:58.855" v="54867" actId="22"/>
@@ -1420,14 +782,6 @@
             <ac:spMk id="3" creationId="{FE6012CC-D3D6-48F7-2E5F-9629BF91ED77}"/>
           </ac:spMkLst>
         </pc:spChg>
-        <pc:spChg chg="del">
-          <ac:chgData name="Li, Cong" userId="025630f4-267e-4cb3-8cd5-8795177f99f4" providerId="ADAL" clId="{929A2CC8-B112-421C-81E2-D5D63B23E300}" dt="2026-09-19T00:53:12.075" v="54825" actId="478"/>
-          <ac:spMkLst>
-            <pc:docMk/>
-            <pc:sldMk cId="3266771034" sldId="625"/>
-            <ac:spMk id="5" creationId="{B89A5EB7-B460-550E-C869-98E5AD9BB835}"/>
-          </ac:spMkLst>
-        </pc:spChg>
         <pc:spChg chg="add mod">
           <ac:chgData name="Li, Cong" userId="025630f4-267e-4cb3-8cd5-8795177f99f4" providerId="ADAL" clId="{929A2CC8-B112-421C-81E2-D5D63B23E300}" dt="2026-09-19T00:53:12.573" v="54826"/>
           <ac:spMkLst>
@@ -1436,60 +790,12 @@
             <ac:spMk id="6" creationId="{6B2B501C-70C4-9D3A-B920-FB4AA98DC6EF}"/>
           </ac:spMkLst>
         </pc:spChg>
-        <pc:spChg chg="del">
-          <ac:chgData name="Li, Cong" userId="025630f4-267e-4cb3-8cd5-8795177f99f4" providerId="ADAL" clId="{929A2CC8-B112-421C-81E2-D5D63B23E300}" dt="2026-09-19T00:53:12.075" v="54825" actId="478"/>
-          <ac:spMkLst>
-            <pc:docMk/>
-            <pc:sldMk cId="3266771034" sldId="625"/>
-            <ac:spMk id="7" creationId="{5FBA7428-E06E-1589-1234-72C4512E800E}"/>
-          </ac:spMkLst>
-        </pc:spChg>
         <pc:spChg chg="add mod">
           <ac:chgData name="Li, Cong" userId="025630f4-267e-4cb3-8cd5-8795177f99f4" providerId="ADAL" clId="{929A2CC8-B112-421C-81E2-D5D63B23E300}" dt="2026-09-19T00:53:12.573" v="54826"/>
           <ac:spMkLst>
             <pc:docMk/>
             <pc:sldMk cId="3266771034" sldId="625"/>
             <ac:spMk id="8" creationId="{A64036BF-37F6-F2EE-E79E-37C38CE7243C}"/>
-          </ac:spMkLst>
-        </pc:spChg>
-        <pc:spChg chg="del mod">
-          <ac:chgData name="Li, Cong" userId="025630f4-267e-4cb3-8cd5-8795177f99f4" providerId="ADAL" clId="{929A2CC8-B112-421C-81E2-D5D63B23E300}" dt="2026-09-19T00:54:55.295" v="54866" actId="478"/>
-          <ac:spMkLst>
-            <pc:docMk/>
-            <pc:sldMk cId="3266771034" sldId="625"/>
-            <ac:spMk id="9" creationId="{8BF65EDA-8915-FD92-390E-66458A0B6339}"/>
-          </ac:spMkLst>
-        </pc:spChg>
-        <pc:spChg chg="del">
-          <ac:chgData name="Li, Cong" userId="025630f4-267e-4cb3-8cd5-8795177f99f4" providerId="ADAL" clId="{929A2CC8-B112-421C-81E2-D5D63B23E300}" dt="2026-09-19T00:53:12.075" v="54825" actId="478"/>
-          <ac:spMkLst>
-            <pc:docMk/>
-            <pc:sldMk cId="3266771034" sldId="625"/>
-            <ac:spMk id="10" creationId="{7A583518-CB94-B2A8-1E83-747C2B572313}"/>
-          </ac:spMkLst>
-        </pc:spChg>
-        <pc:spChg chg="del">
-          <ac:chgData name="Li, Cong" userId="025630f4-267e-4cb3-8cd5-8795177f99f4" providerId="ADAL" clId="{929A2CC8-B112-421C-81E2-D5D63B23E300}" dt="2026-09-19T00:53:12.075" v="54825" actId="478"/>
-          <ac:spMkLst>
-            <pc:docMk/>
-            <pc:sldMk cId="3266771034" sldId="625"/>
-            <ac:spMk id="11" creationId="{C1797B73-0227-AD71-ADE1-556888D93561}"/>
-          </ac:spMkLst>
-        </pc:spChg>
-        <pc:spChg chg="del">
-          <ac:chgData name="Li, Cong" userId="025630f4-267e-4cb3-8cd5-8795177f99f4" providerId="ADAL" clId="{929A2CC8-B112-421C-81E2-D5D63B23E300}" dt="2026-09-19T00:53:12.075" v="54825" actId="478"/>
-          <ac:spMkLst>
-            <pc:docMk/>
-            <pc:sldMk cId="3266771034" sldId="625"/>
-            <ac:spMk id="12" creationId="{8625B5D7-74A1-7C57-D39C-018221B26ACF}"/>
-          </ac:spMkLst>
-        </pc:spChg>
-        <pc:spChg chg="del">
-          <ac:chgData name="Li, Cong" userId="025630f4-267e-4cb3-8cd5-8795177f99f4" providerId="ADAL" clId="{929A2CC8-B112-421C-81E2-D5D63B23E300}" dt="2026-09-19T00:53:12.075" v="54825" actId="478"/>
-          <ac:spMkLst>
-            <pc:docMk/>
-            <pc:sldMk cId="3266771034" sldId="625"/>
-            <ac:spMk id="14" creationId="{64EFE21A-F90A-16B0-FA75-B37DEC417B2A}"/>
           </ac:spMkLst>
         </pc:spChg>
         <pc:spChg chg="add mod">
@@ -1532,22 +838,6 @@
             <ac:spMk id="32" creationId="{CF8EF8D0-E508-D3E2-3DFB-3B4FF0F4A80A}"/>
           </ac:spMkLst>
         </pc:spChg>
-        <pc:cxnChg chg="del mod">
-          <ac:chgData name="Li, Cong" userId="025630f4-267e-4cb3-8cd5-8795177f99f4" providerId="ADAL" clId="{929A2CC8-B112-421C-81E2-D5D63B23E300}" dt="2026-09-19T00:53:12.075" v="54825" actId="478"/>
-          <ac:cxnSpMkLst>
-            <pc:docMk/>
-            <pc:sldMk cId="3266771034" sldId="625"/>
-            <ac:cxnSpMk id="13" creationId="{A4876845-5D7B-E517-5470-F735A72A279E}"/>
-          </ac:cxnSpMkLst>
-        </pc:cxnChg>
-        <pc:cxnChg chg="del mod">
-          <ac:chgData name="Li, Cong" userId="025630f4-267e-4cb3-8cd5-8795177f99f4" providerId="ADAL" clId="{929A2CC8-B112-421C-81E2-D5D63B23E300}" dt="2026-09-19T00:53:12.075" v="54825" actId="478"/>
-          <ac:cxnSpMkLst>
-            <pc:docMk/>
-            <pc:sldMk cId="3266771034" sldId="625"/>
-            <ac:cxnSpMk id="15" creationId="{3B29EF88-5A07-7A4C-4013-6A130B48B39F}"/>
-          </ac:cxnSpMkLst>
-        </pc:cxnChg>
         <pc:cxnChg chg="add mod">
           <ac:chgData name="Li, Cong" userId="025630f4-267e-4cb3-8cd5-8795177f99f4" providerId="ADAL" clId="{929A2CC8-B112-421C-81E2-D5D63B23E300}" dt="2026-09-19T00:54:27.228" v="54861" actId="14100"/>
           <ac:cxnSpMkLst>
@@ -1572,14 +862,6 @@
             <ac:cxnSpMk id="18" creationId="{BF388A05-AB08-57F0-00EF-530A458F5DC8}"/>
           </ac:cxnSpMkLst>
         </pc:cxnChg>
-        <pc:cxnChg chg="del mod">
-          <ac:chgData name="Li, Cong" userId="025630f4-267e-4cb3-8cd5-8795177f99f4" providerId="ADAL" clId="{929A2CC8-B112-421C-81E2-D5D63B23E300}" dt="2026-09-19T00:53:12.075" v="54825" actId="478"/>
-          <ac:cxnSpMkLst>
-            <pc:docMk/>
-            <pc:sldMk cId="3266771034" sldId="625"/>
-            <ac:cxnSpMk id="19" creationId="{ED1E06D1-ED96-AA41-378F-8FE51C1B325A}"/>
-          </ac:cxnSpMkLst>
-        </pc:cxnChg>
         <pc:cxnChg chg="add mod">
           <ac:chgData name="Li, Cong" userId="025630f4-267e-4cb3-8cd5-8795177f99f4" providerId="ADAL" clId="{929A2CC8-B112-421C-81E2-D5D63B23E300}" dt="2026-09-19T00:54:22.333" v="54859" actId="14100"/>
           <ac:cxnSpMkLst>
@@ -1601,46 +883,6 @@
             <pc:docMk/>
             <pc:sldMk cId="2468417659" sldId="626"/>
             <ac:spMk id="2" creationId="{CA3DDD90-1F05-AE81-32D5-970C5285EECD}"/>
-          </ac:spMkLst>
-        </pc:spChg>
-        <pc:spChg chg="del">
-          <ac:chgData name="Li, Cong" userId="025630f4-267e-4cb3-8cd5-8795177f99f4" providerId="ADAL" clId="{929A2CC8-B112-421C-81E2-D5D63B23E300}" dt="2026-09-19T00:48:51.685" v="54703" actId="478"/>
-          <ac:spMkLst>
-            <pc:docMk/>
-            <pc:sldMk cId="2468417659" sldId="626"/>
-            <ac:spMk id="3" creationId="{0C8D761B-372C-12FC-6B07-95E93C3F6CAB}"/>
-          </ac:spMkLst>
-        </pc:spChg>
-        <pc:spChg chg="del">
-          <ac:chgData name="Li, Cong" userId="025630f4-267e-4cb3-8cd5-8795177f99f4" providerId="ADAL" clId="{929A2CC8-B112-421C-81E2-D5D63B23E300}" dt="2026-09-19T00:48:51.685" v="54703" actId="478"/>
-          <ac:spMkLst>
-            <pc:docMk/>
-            <pc:sldMk cId="2468417659" sldId="626"/>
-            <ac:spMk id="5" creationId="{7924490E-47E2-6458-19F0-57367762BB33}"/>
-          </ac:spMkLst>
-        </pc:spChg>
-        <pc:spChg chg="del">
-          <ac:chgData name="Li, Cong" userId="025630f4-267e-4cb3-8cd5-8795177f99f4" providerId="ADAL" clId="{929A2CC8-B112-421C-81E2-D5D63B23E300}" dt="2026-09-19T00:48:51.685" v="54703" actId="478"/>
-          <ac:spMkLst>
-            <pc:docMk/>
-            <pc:sldMk cId="2468417659" sldId="626"/>
-            <ac:spMk id="7" creationId="{B4085AC3-8D4C-1A57-1FF9-E8075F78D232}"/>
-          </ac:spMkLst>
-        </pc:spChg>
-        <pc:spChg chg="del">
-          <ac:chgData name="Li, Cong" userId="025630f4-267e-4cb3-8cd5-8795177f99f4" providerId="ADAL" clId="{929A2CC8-B112-421C-81E2-D5D63B23E300}" dt="2026-09-19T00:48:51.685" v="54703" actId="478"/>
-          <ac:spMkLst>
-            <pc:docMk/>
-            <pc:sldMk cId="2468417659" sldId="626"/>
-            <ac:spMk id="8" creationId="{F9F723A9-3F79-130C-C174-876EE7503125}"/>
-          </ac:spMkLst>
-        </pc:spChg>
-        <pc:spChg chg="del">
-          <ac:chgData name="Li, Cong" userId="025630f4-267e-4cb3-8cd5-8795177f99f4" providerId="ADAL" clId="{929A2CC8-B112-421C-81E2-D5D63B23E300}" dt="2026-09-19T00:48:51.685" v="54703" actId="478"/>
-          <ac:spMkLst>
-            <pc:docMk/>
-            <pc:sldMk cId="2468417659" sldId="626"/>
-            <ac:spMk id="9" creationId="{814173AB-90AA-8829-E092-8479EC85683D}"/>
           </ac:spMkLst>
         </pc:spChg>
         <pc:spChg chg="add ord">
@@ -1689,30 +931,6 @@
             <pc:docMk/>
             <pc:sldMk cId="2468417659" sldId="626"/>
             <ac:spMk id="19" creationId="{A84E372A-6A1A-4745-1F1E-0D659AFA2379}"/>
-          </ac:spMkLst>
-        </pc:spChg>
-        <pc:spChg chg="del">
-          <ac:chgData name="Li, Cong" userId="025630f4-267e-4cb3-8cd5-8795177f99f4" providerId="ADAL" clId="{929A2CC8-B112-421C-81E2-D5D63B23E300}" dt="2026-09-19T00:48:51.685" v="54703" actId="478"/>
-          <ac:spMkLst>
-            <pc:docMk/>
-            <pc:sldMk cId="2468417659" sldId="626"/>
-            <ac:spMk id="20" creationId="{BC4A6A28-5102-37CC-B13D-EAF38A4A7B33}"/>
-          </ac:spMkLst>
-        </pc:spChg>
-        <pc:spChg chg="del">
-          <ac:chgData name="Li, Cong" userId="025630f4-267e-4cb3-8cd5-8795177f99f4" providerId="ADAL" clId="{929A2CC8-B112-421C-81E2-D5D63B23E300}" dt="2026-09-19T00:48:51.685" v="54703" actId="478"/>
-          <ac:spMkLst>
-            <pc:docMk/>
-            <pc:sldMk cId="2468417659" sldId="626"/>
-            <ac:spMk id="22" creationId="{5647A7EF-5470-DE76-FD93-E3CD77D68C46}"/>
-          </ac:spMkLst>
-        </pc:spChg>
-        <pc:spChg chg="del">
-          <ac:chgData name="Li, Cong" userId="025630f4-267e-4cb3-8cd5-8795177f99f4" providerId="ADAL" clId="{929A2CC8-B112-421C-81E2-D5D63B23E300}" dt="2026-09-19T00:48:51.685" v="54703" actId="478"/>
-          <ac:spMkLst>
-            <pc:docMk/>
-            <pc:sldMk cId="2468417659" sldId="626"/>
-            <ac:spMk id="23" creationId="{8189E09E-2AD8-DCC8-120A-29198618CD75}"/>
           </ac:spMkLst>
         </pc:spChg>
         <pc:spChg chg="add mod">
@@ -1802,14 +1020,6 @@
             <ac:spMk id="3" creationId="{CCD33728-48CF-9EFE-AB19-2EA381346367}"/>
           </ac:spMkLst>
         </pc:spChg>
-        <pc:spChg chg="add del mod">
-          <ac:chgData name="Li, Cong" userId="025630f4-267e-4cb3-8cd5-8795177f99f4" providerId="ADAL" clId="{929A2CC8-B112-421C-81E2-D5D63B23E300}" dt="2026-09-19T00:51:44.219" v="54809" actId="21"/>
-          <ac:spMkLst>
-            <pc:docMk/>
-            <pc:sldMk cId="3432225247" sldId="627"/>
-            <ac:spMk id="6" creationId="{F603FAB5-1329-6F15-82AA-E0D4D3FFF91E}"/>
-          </ac:spMkLst>
-        </pc:spChg>
         <pc:spChg chg="mod">
           <ac:chgData name="Li, Cong" userId="025630f4-267e-4cb3-8cd5-8795177f99f4" providerId="ADAL" clId="{929A2CC8-B112-421C-81E2-D5D63B23E300}" dt="2026-09-19T00:48:18.418" v="54702" actId="1076"/>
           <ac:spMkLst>
@@ -1824,30 +1034,6 @@
             <pc:docMk/>
             <pc:sldMk cId="3432225247" sldId="627"/>
             <ac:spMk id="9" creationId="{12D67916-DC7D-3D40-C9BC-F4ACD412B98D}"/>
-          </ac:spMkLst>
-        </pc:spChg>
-        <pc:spChg chg="add del mod">
-          <ac:chgData name="Li, Cong" userId="025630f4-267e-4cb3-8cd5-8795177f99f4" providerId="ADAL" clId="{929A2CC8-B112-421C-81E2-D5D63B23E300}" dt="2026-09-19T00:51:44.219" v="54809" actId="21"/>
-          <ac:spMkLst>
-            <pc:docMk/>
-            <pc:sldMk cId="3432225247" sldId="627"/>
-            <ac:spMk id="10" creationId="{AF18DE09-0264-9BDD-0932-24ECA0A3FB21}"/>
-          </ac:spMkLst>
-        </pc:spChg>
-        <pc:spChg chg="add del mod">
-          <ac:chgData name="Li, Cong" userId="025630f4-267e-4cb3-8cd5-8795177f99f4" providerId="ADAL" clId="{929A2CC8-B112-421C-81E2-D5D63B23E300}" dt="2026-09-19T00:51:44.219" v="54809" actId="21"/>
-          <ac:spMkLst>
-            <pc:docMk/>
-            <pc:sldMk cId="3432225247" sldId="627"/>
-            <ac:spMk id="11" creationId="{E11D0156-9DA3-A788-6F35-62688E0A91A6}"/>
-          </ac:spMkLst>
-        </pc:spChg>
-        <pc:spChg chg="add del mod">
-          <ac:chgData name="Li, Cong" userId="025630f4-267e-4cb3-8cd5-8795177f99f4" providerId="ADAL" clId="{929A2CC8-B112-421C-81E2-D5D63B23E300}" dt="2026-09-19T00:51:44.219" v="54809" actId="21"/>
-          <ac:spMkLst>
-            <pc:docMk/>
-            <pc:sldMk cId="3432225247" sldId="627"/>
-            <ac:spMk id="12" creationId="{1DBAB6AB-AFCF-D986-6D5B-9F833ADE67DB}"/>
           </ac:spMkLst>
         </pc:spChg>
         <pc:spChg chg="mod">
@@ -1935,22 +1121,6 @@
             <ac:spMk id="2" creationId="{85AF327F-550F-D2E9-683A-A6B33DC0ED4E}"/>
           </ac:spMkLst>
         </pc:spChg>
-        <pc:spChg chg="del">
-          <ac:chgData name="Li, Cong" userId="025630f4-267e-4cb3-8cd5-8795177f99f4" providerId="ADAL" clId="{929A2CC8-B112-421C-81E2-D5D63B23E300}" dt="2026-09-19T02:27:23.964" v="55540" actId="478"/>
-          <ac:spMkLst>
-            <pc:docMk/>
-            <pc:sldMk cId="2507804104" sldId="630"/>
-            <ac:spMk id="3" creationId="{AFA0136E-C4F5-292C-971E-D3993CD5EDE4}"/>
-          </ac:spMkLst>
-        </pc:spChg>
-        <pc:spChg chg="del">
-          <ac:chgData name="Li, Cong" userId="025630f4-267e-4cb3-8cd5-8795177f99f4" providerId="ADAL" clId="{929A2CC8-B112-421C-81E2-D5D63B23E300}" dt="2026-09-19T02:27:22.204" v="55539" actId="478"/>
-          <ac:spMkLst>
-            <pc:docMk/>
-            <pc:sldMk cId="2507804104" sldId="630"/>
-            <ac:spMk id="6" creationId="{575C254C-E7C1-4091-6751-0285F90F7E92}"/>
-          </ac:spMkLst>
-        </pc:spChg>
         <pc:spChg chg="add mod">
           <ac:chgData name="Li, Cong" userId="025630f4-267e-4cb3-8cd5-8795177f99f4" providerId="ADAL" clId="{929A2CC8-B112-421C-81E2-D5D63B23E300}" dt="2026-09-19T02:30:07.732" v="55723" actId="1076"/>
           <ac:spMkLst>
@@ -1997,14 +1167,6 @@
             <pc:docMk/>
             <pc:sldMk cId="2507804104" sldId="630"/>
             <ac:graphicFrameMk id="4" creationId="{5FE853CF-975D-C119-EEEF-5043E68F93DE}"/>
-          </ac:graphicFrameMkLst>
-        </pc:graphicFrameChg>
-        <pc:graphicFrameChg chg="add del mod modGraphic">
-          <ac:chgData name="Li, Cong" userId="025630f4-267e-4cb3-8cd5-8795177f99f4" providerId="ADAL" clId="{929A2CC8-B112-421C-81E2-D5D63B23E300}" dt="2026-09-19T02:31:28.643" v="55737" actId="478"/>
-          <ac:graphicFrameMkLst>
-            <pc:docMk/>
-            <pc:sldMk cId="2507804104" sldId="630"/>
-            <ac:graphicFrameMk id="9" creationId="{B5A8BC72-06AC-C6C7-CB0F-76308077677A}"/>
           </ac:graphicFrameMkLst>
         </pc:graphicFrameChg>
         <pc:cxnChg chg="add mod">
@@ -2070,14 +1232,6 @@
             <ac:spMk id="14" creationId="{6440592D-983F-E900-4E7C-59B42B872887}"/>
           </ac:spMkLst>
         </pc:spChg>
-        <pc:graphicFrameChg chg="del">
-          <ac:chgData name="Li, Cong" userId="025630f4-267e-4cb3-8cd5-8795177f99f4" providerId="ADAL" clId="{929A2CC8-B112-421C-81E2-D5D63B23E300}" dt="2026-09-19T02:39:48.802" v="55907" actId="478"/>
-          <ac:graphicFrameMkLst>
-            <pc:docMk/>
-            <pc:sldMk cId="3430215282" sldId="631"/>
-            <ac:graphicFrameMk id="4" creationId="{5E00AF3C-35EF-D9BC-1B20-B42D1A9BE591}"/>
-          </ac:graphicFrameMkLst>
-        </pc:graphicFrameChg>
         <pc:graphicFrameChg chg="mod">
           <ac:chgData name="Li, Cong" userId="025630f4-267e-4cb3-8cd5-8795177f99f4" providerId="ADAL" clId="{929A2CC8-B112-421C-81E2-D5D63B23E300}" dt="2026-09-19T02:37:18.638" v="55872" actId="1035"/>
           <ac:graphicFrameMkLst>
@@ -2133,38 +1287,6 @@
             <ac:spMk id="3" creationId="{A735C99B-D4A8-7FCF-B954-30F8060A1B84}"/>
           </ac:spMkLst>
         </pc:spChg>
-        <pc:spChg chg="del">
-          <ac:chgData name="Li, Cong" userId="025630f4-267e-4cb3-8cd5-8795177f99f4" providerId="ADAL" clId="{929A2CC8-B112-421C-81E2-D5D63B23E300}" dt="2026-09-19T02:40:27.030" v="55912" actId="478"/>
-          <ac:spMkLst>
-            <pc:docMk/>
-            <pc:sldMk cId="922240735" sldId="632"/>
-            <ac:spMk id="6" creationId="{03949801-E596-B991-801F-6137DB7B53EE}"/>
-          </ac:spMkLst>
-        </pc:spChg>
-        <pc:spChg chg="del">
-          <ac:chgData name="Li, Cong" userId="025630f4-267e-4cb3-8cd5-8795177f99f4" providerId="ADAL" clId="{929A2CC8-B112-421C-81E2-D5D63B23E300}" dt="2026-09-19T02:40:27.030" v="55912" actId="478"/>
-          <ac:spMkLst>
-            <pc:docMk/>
-            <pc:sldMk cId="922240735" sldId="632"/>
-            <ac:spMk id="11" creationId="{0617DEA2-9BA3-CEED-9338-78F891F7BD4D}"/>
-          </ac:spMkLst>
-        </pc:spChg>
-        <pc:spChg chg="add del">
-          <ac:chgData name="Li, Cong" userId="025630f4-267e-4cb3-8cd5-8795177f99f4" providerId="ADAL" clId="{929A2CC8-B112-421C-81E2-D5D63B23E300}" dt="2026-09-19T02:41:47.449" v="56053" actId="478"/>
-          <ac:spMkLst>
-            <pc:docMk/>
-            <pc:sldMk cId="922240735" sldId="632"/>
-            <ac:spMk id="13" creationId="{59C57A15-792D-093E-7253-8BFA5A0F0C9E}"/>
-          </ac:spMkLst>
-        </pc:spChg>
-        <pc:spChg chg="del">
-          <ac:chgData name="Li, Cong" userId="025630f4-267e-4cb3-8cd5-8795177f99f4" providerId="ADAL" clId="{929A2CC8-B112-421C-81E2-D5D63B23E300}" dt="2026-09-19T02:40:27.030" v="55912" actId="478"/>
-          <ac:spMkLst>
-            <pc:docMk/>
-            <pc:sldMk cId="922240735" sldId="632"/>
-            <ac:spMk id="14" creationId="{1C9ADC37-6384-7965-35B5-79566CE1041A}"/>
-          </ac:spMkLst>
-        </pc:spChg>
         <pc:spChg chg="add mod">
           <ac:chgData name="Li, Cong" userId="025630f4-267e-4cb3-8cd5-8795177f99f4" providerId="ADAL" clId="{929A2CC8-B112-421C-81E2-D5D63B23E300}" dt="2026-09-19T07:00:05.214" v="60637" actId="20577"/>
           <ac:spMkLst>
@@ -2173,30 +1295,6 @@
             <ac:spMk id="17" creationId="{FAD11E25-0EC6-DE38-E806-446644862B85}"/>
           </ac:spMkLst>
         </pc:spChg>
-        <pc:cxnChg chg="del mod">
-          <ac:chgData name="Li, Cong" userId="025630f4-267e-4cb3-8cd5-8795177f99f4" providerId="ADAL" clId="{929A2CC8-B112-421C-81E2-D5D63B23E300}" dt="2026-09-19T02:40:29.968" v="55913" actId="478"/>
-          <ac:cxnSpMkLst>
-            <pc:docMk/>
-            <pc:sldMk cId="922240735" sldId="632"/>
-            <ac:cxnSpMk id="8" creationId="{2DB14DB3-ADEC-A00E-1433-FFEA6F09E547}"/>
-          </ac:cxnSpMkLst>
-        </pc:cxnChg>
-        <pc:cxnChg chg="del mod">
-          <ac:chgData name="Li, Cong" userId="025630f4-267e-4cb3-8cd5-8795177f99f4" providerId="ADAL" clId="{929A2CC8-B112-421C-81E2-D5D63B23E300}" dt="2026-09-19T02:40:27.030" v="55912" actId="478"/>
-          <ac:cxnSpMkLst>
-            <pc:docMk/>
-            <pc:sldMk cId="922240735" sldId="632"/>
-            <ac:cxnSpMk id="12" creationId="{27FE812F-E406-3F44-AA04-024DA181EDC8}"/>
-          </ac:cxnSpMkLst>
-        </pc:cxnChg>
-        <pc:cxnChg chg="del mod">
-          <ac:chgData name="Li, Cong" userId="025630f4-267e-4cb3-8cd5-8795177f99f4" providerId="ADAL" clId="{929A2CC8-B112-421C-81E2-D5D63B23E300}" dt="2026-09-19T02:40:27.030" v="55912" actId="478"/>
-          <ac:cxnSpMkLst>
-            <pc:docMk/>
-            <pc:sldMk cId="922240735" sldId="632"/>
-            <ac:cxnSpMk id="15" creationId="{52FFDE5B-072B-88D9-4DDA-B548C0D0F9EA}"/>
-          </ac:cxnSpMkLst>
-        </pc:cxnChg>
       </pc:sldChg>
       <pc:sldChg chg="addSp delSp modSp add mod modAnim">
         <pc:chgData name="Li, Cong" userId="025630f4-267e-4cb3-8cd5-8795177f99f4" providerId="ADAL" clId="{929A2CC8-B112-421C-81E2-D5D63B23E300}" dt="2026-09-19T07:01:18.568" v="60663" actId="20577"/>
@@ -2220,22 +1318,6 @@
             <ac:spMk id="3" creationId="{FF149F2E-348A-1A59-EA12-6150E7DB8589}"/>
           </ac:spMkLst>
         </pc:spChg>
-        <pc:spChg chg="add del mod">
-          <ac:chgData name="Li, Cong" userId="025630f4-267e-4cb3-8cd5-8795177f99f4" providerId="ADAL" clId="{929A2CC8-B112-421C-81E2-D5D63B23E300}" dt="2026-09-19T02:51:36.200" v="56178" actId="478"/>
-          <ac:spMkLst>
-            <pc:docMk/>
-            <pc:sldMk cId="1132893933" sldId="633"/>
-            <ac:spMk id="4" creationId="{1AF42171-06DF-14EC-2C74-F71C3C6BD5C7}"/>
-          </ac:spMkLst>
-        </pc:spChg>
-        <pc:spChg chg="add mod">
-          <ac:chgData name="Li, Cong" userId="025630f4-267e-4cb3-8cd5-8795177f99f4" providerId="ADAL" clId="{929A2CC8-B112-421C-81E2-D5D63B23E300}" dt="2026-09-19T02:51:35.330" v="56176" actId="20577"/>
-          <ac:spMkLst>
-            <pc:docMk/>
-            <pc:sldMk cId="1132893933" sldId="633"/>
-            <ac:spMk id="6" creationId="{AECB0F6A-63B5-A8AC-4321-6A2B2C85B2F2}"/>
-          </ac:spMkLst>
-        </pc:spChg>
       </pc:sldChg>
       <pc:sldChg chg="addSp delSp modSp add mod modAnim">
         <pc:chgData name="Li, Cong" userId="025630f4-267e-4cb3-8cd5-8795177f99f4" providerId="ADAL" clId="{929A2CC8-B112-421C-81E2-D5D63B23E300}" dt="2026-09-19T02:59:12.438" v="56752" actId="1035"/>
@@ -2249,22 +1331,6 @@
             <pc:docMk/>
             <pc:sldMk cId="1985883900" sldId="634"/>
             <ac:spMk id="2" creationId="{C5B69519-C1DC-B6B8-133C-3D47F5EA6478}"/>
-          </ac:spMkLst>
-        </pc:spChg>
-        <pc:spChg chg="del">
-          <ac:chgData name="Li, Cong" userId="025630f4-267e-4cb3-8cd5-8795177f99f4" providerId="ADAL" clId="{929A2CC8-B112-421C-81E2-D5D63B23E300}" dt="2026-09-19T02:58:28.447" v="56734" actId="478"/>
-          <ac:spMkLst>
-            <pc:docMk/>
-            <pc:sldMk cId="1985883900" sldId="634"/>
-            <ac:spMk id="3" creationId="{157177A7-807D-4B46-B7EC-C1B5AA2B9954}"/>
-          </ac:spMkLst>
-        </pc:spChg>
-        <pc:spChg chg="add del mod">
-          <ac:chgData name="Li, Cong" userId="025630f4-267e-4cb3-8cd5-8795177f99f4" providerId="ADAL" clId="{929A2CC8-B112-421C-81E2-D5D63B23E300}" dt="2026-09-19T02:58:30.780" v="56735" actId="478"/>
-          <ac:spMkLst>
-            <pc:docMk/>
-            <pc:sldMk cId="1985883900" sldId="634"/>
-            <ac:spMk id="4" creationId="{661F4648-12CB-69E2-8FF4-813BEAB09419}"/>
           </ac:spMkLst>
         </pc:spChg>
         <pc:picChg chg="add mod">
@@ -2321,13 +1387,6 @@
             <ac:spMk id="3" creationId="{E7552F50-079F-B5B7-1B14-D12DB5C83694}"/>
           </ac:spMkLst>
         </pc:spChg>
-      </pc:sldChg>
-      <pc:sldChg chg="add del">
-        <pc:chgData name="Li, Cong" userId="025630f4-267e-4cb3-8cd5-8795177f99f4" providerId="ADAL" clId="{929A2CC8-B112-421C-81E2-D5D63B23E300}" dt="2026-09-19T03:04:01.812" v="56917"/>
-        <pc:sldMkLst>
-          <pc:docMk/>
-          <pc:sldMk cId="2254058632" sldId="636"/>
-        </pc:sldMkLst>
       </pc:sldChg>
       <pc:sldChg chg="modSp add mod">
         <pc:chgData name="Li, Cong" userId="025630f4-267e-4cb3-8cd5-8795177f99f4" providerId="ADAL" clId="{929A2CC8-B112-421C-81E2-D5D63B23E300}" dt="2026-09-19T07:08:52.981" v="60827" actId="20577"/>
@@ -2398,14 +1457,6 @@
             <ac:spMk id="4" creationId="{C4FF1456-27E6-5FBC-FD89-3E48974EF3BA}"/>
           </ac:spMkLst>
         </pc:spChg>
-        <pc:spChg chg="del">
-          <ac:chgData name="Li, Cong" userId="025630f4-267e-4cb3-8cd5-8795177f99f4" providerId="ADAL" clId="{929A2CC8-B112-421C-81E2-D5D63B23E300}" dt="2026-09-19T05:57:38.021" v="58381" actId="478"/>
-          <ac:spMkLst>
-            <pc:docMk/>
-            <pc:sldMk cId="2846405356" sldId="638"/>
-            <ac:spMk id="6" creationId="{49662132-4ED3-1831-5D0D-0D4D455CFC24}"/>
-          </ac:spMkLst>
-        </pc:spChg>
         <pc:spChg chg="mod">
           <ac:chgData name="Li, Cong" userId="025630f4-267e-4cb3-8cd5-8795177f99f4" providerId="ADAL" clId="{929A2CC8-B112-421C-81E2-D5D63B23E300}" dt="2026-09-19T06:04:26.234" v="58554" actId="1035"/>
           <ac:spMkLst>
@@ -2420,22 +1471,6 @@
             <pc:docMk/>
             <pc:sldMk cId="2846405356" sldId="638"/>
             <ac:spMk id="10" creationId="{9C4ADB86-C840-FC7D-C592-86E7D0A8BD20}"/>
-          </ac:spMkLst>
-        </pc:spChg>
-        <pc:spChg chg="del">
-          <ac:chgData name="Li, Cong" userId="025630f4-267e-4cb3-8cd5-8795177f99f4" providerId="ADAL" clId="{929A2CC8-B112-421C-81E2-D5D63B23E300}" dt="2026-09-19T05:57:41.014" v="58383" actId="478"/>
-          <ac:spMkLst>
-            <pc:docMk/>
-            <pc:sldMk cId="2846405356" sldId="638"/>
-            <ac:spMk id="11" creationId="{BDCC001A-0398-7A40-AB0F-DA9F8462321A}"/>
-          </ac:spMkLst>
-        </pc:spChg>
-        <pc:spChg chg="del">
-          <ac:chgData name="Li, Cong" userId="025630f4-267e-4cb3-8cd5-8795177f99f4" providerId="ADAL" clId="{929A2CC8-B112-421C-81E2-D5D63B23E300}" dt="2026-09-19T05:57:39.363" v="58382" actId="478"/>
-          <ac:spMkLst>
-            <pc:docMk/>
-            <pc:sldMk cId="2846405356" sldId="638"/>
-            <ac:spMk id="14" creationId="{44C833C0-4430-5D8E-D088-15AFE6A933D7}"/>
           </ac:spMkLst>
         </pc:spChg>
         <pc:spChg chg="add mod">
@@ -2470,30 +1505,6 @@
             <ac:graphicFrameMk id="19" creationId="{421BAA9A-FF2D-F2C4-5DBF-0F5D7922535C}"/>
           </ac:graphicFrameMkLst>
         </pc:graphicFrameChg>
-        <pc:cxnChg chg="del mod">
-          <ac:chgData name="Li, Cong" userId="025630f4-267e-4cb3-8cd5-8795177f99f4" providerId="ADAL" clId="{929A2CC8-B112-421C-81E2-D5D63B23E300}" dt="2026-09-19T05:57:35.035" v="58379" actId="478"/>
-          <ac:cxnSpMkLst>
-            <pc:docMk/>
-            <pc:sldMk cId="2846405356" sldId="638"/>
-            <ac:cxnSpMk id="8" creationId="{4E7C0211-07F1-26BC-08BE-6DA8FA6557DF}"/>
-          </ac:cxnSpMkLst>
-        </pc:cxnChg>
-        <pc:cxnChg chg="del mod">
-          <ac:chgData name="Li, Cong" userId="025630f4-267e-4cb3-8cd5-8795177f99f4" providerId="ADAL" clId="{929A2CC8-B112-421C-81E2-D5D63B23E300}" dt="2026-09-19T05:57:41.621" v="58384" actId="478"/>
-          <ac:cxnSpMkLst>
-            <pc:docMk/>
-            <pc:sldMk cId="2846405356" sldId="638"/>
-            <ac:cxnSpMk id="12" creationId="{FE1EAB5B-41C0-E5D9-3D97-A17A78CD9156}"/>
-          </ac:cxnSpMkLst>
-        </pc:cxnChg>
-        <pc:cxnChg chg="del mod">
-          <ac:chgData name="Li, Cong" userId="025630f4-267e-4cb3-8cd5-8795177f99f4" providerId="ADAL" clId="{929A2CC8-B112-421C-81E2-D5D63B23E300}" dt="2026-09-19T05:57:35.990" v="58380" actId="478"/>
-          <ac:cxnSpMkLst>
-            <pc:docMk/>
-            <pc:sldMk cId="2846405356" sldId="638"/>
-            <ac:cxnSpMk id="15" creationId="{B661823A-2460-24B5-A284-595C9043CA4C}"/>
-          </ac:cxnSpMkLst>
-        </pc:cxnChg>
         <pc:cxnChg chg="add">
           <ac:chgData name="Li, Cong" userId="025630f4-267e-4cb3-8cd5-8795177f99f4" providerId="ADAL" clId="{929A2CC8-B112-421C-81E2-D5D63B23E300}" dt="2026-09-19T06:06:07.749" v="58636" actId="11529"/>
           <ac:cxnSpMkLst>
@@ -2525,36 +1536,12 @@
             <ac:spMk id="3" creationId="{E933E9C1-7B78-7588-6EEE-E9F4F5AC18C6}"/>
           </ac:spMkLst>
         </pc:spChg>
-        <pc:spChg chg="del">
-          <ac:chgData name="Li, Cong" userId="025630f4-267e-4cb3-8cd5-8795177f99f4" providerId="ADAL" clId="{929A2CC8-B112-421C-81E2-D5D63B23E300}" dt="2026-09-19T06:09:56.885" v="58641" actId="478"/>
-          <ac:spMkLst>
-            <pc:docMk/>
-            <pc:sldMk cId="2592862289" sldId="639"/>
-            <ac:spMk id="4" creationId="{0BDB1B05-3B3E-69E5-D817-752FCDD93A2F}"/>
-          </ac:spMkLst>
-        </pc:spChg>
-        <pc:spChg chg="del">
-          <ac:chgData name="Li, Cong" userId="025630f4-267e-4cb3-8cd5-8795177f99f4" providerId="ADAL" clId="{929A2CC8-B112-421C-81E2-D5D63B23E300}" dt="2026-09-19T06:09:56.885" v="58641" actId="478"/>
-          <ac:spMkLst>
-            <pc:docMk/>
-            <pc:sldMk cId="2592862289" sldId="639"/>
-            <ac:spMk id="7" creationId="{A9A57DA4-35A2-5794-140F-44CE07386574}"/>
-          </ac:spMkLst>
-        </pc:spChg>
         <pc:spChg chg="add mod">
           <ac:chgData name="Li, Cong" userId="025630f4-267e-4cb3-8cd5-8795177f99f4" providerId="ADAL" clId="{929A2CC8-B112-421C-81E2-D5D63B23E300}" dt="2026-09-19T06:17:26.340" v="59052" actId="1076"/>
           <ac:spMkLst>
             <pc:docMk/>
             <pc:sldMk cId="2592862289" sldId="639"/>
             <ac:spMk id="8" creationId="{BBDB60B1-19C0-9412-8FB7-DC7CCB5DC740}"/>
-          </ac:spMkLst>
-        </pc:spChg>
-        <pc:spChg chg="del">
-          <ac:chgData name="Li, Cong" userId="025630f4-267e-4cb3-8cd5-8795177f99f4" providerId="ADAL" clId="{929A2CC8-B112-421C-81E2-D5D63B23E300}" dt="2026-09-19T06:09:53.789" v="58640" actId="478"/>
-          <ac:spMkLst>
-            <pc:docMk/>
-            <pc:sldMk cId="2592862289" sldId="639"/>
-            <ac:spMk id="10" creationId="{AB8C5C34-5B65-A075-34A7-5B27E8983465}"/>
           </ac:spMkLst>
         </pc:spChg>
         <pc:spChg chg="add mod">
@@ -2573,46 +1560,6 @@
             <ac:spMk id="15" creationId="{8A48EE64-F5D6-4A4A-E74D-BF301A504C8D}"/>
           </ac:spMkLst>
         </pc:spChg>
-        <pc:spChg chg="del">
-          <ac:chgData name="Li, Cong" userId="025630f4-267e-4cb3-8cd5-8795177f99f4" providerId="ADAL" clId="{929A2CC8-B112-421C-81E2-D5D63B23E300}" dt="2026-09-19T06:10:00.758" v="58642" actId="478"/>
-          <ac:spMkLst>
-            <pc:docMk/>
-            <pc:sldMk cId="2592862289" sldId="639"/>
-            <ac:spMk id="17" creationId="{304153A8-F97F-61C2-FE40-9B4A728D40CF}"/>
-          </ac:spMkLst>
-        </pc:spChg>
-        <pc:graphicFrameChg chg="del">
-          <ac:chgData name="Li, Cong" userId="025630f4-267e-4cb3-8cd5-8795177f99f4" providerId="ADAL" clId="{929A2CC8-B112-421C-81E2-D5D63B23E300}" dt="2026-09-19T06:09:56.885" v="58641" actId="478"/>
-          <ac:graphicFrameMkLst>
-            <pc:docMk/>
-            <pc:sldMk cId="2592862289" sldId="639"/>
-            <ac:graphicFrameMk id="9" creationId="{C10AD890-EBE8-6016-5E49-5A1CE6526F29}"/>
-          </ac:graphicFrameMkLst>
-        </pc:graphicFrameChg>
-        <pc:graphicFrameChg chg="del">
-          <ac:chgData name="Li, Cong" userId="025630f4-267e-4cb3-8cd5-8795177f99f4" providerId="ADAL" clId="{929A2CC8-B112-421C-81E2-D5D63B23E300}" dt="2026-09-19T06:09:56.885" v="58641" actId="478"/>
-          <ac:graphicFrameMkLst>
-            <pc:docMk/>
-            <pc:sldMk cId="2592862289" sldId="639"/>
-            <ac:graphicFrameMk id="13" creationId="{7398E2EA-1674-8CE2-2164-A5B4133BFA07}"/>
-          </ac:graphicFrameMkLst>
-        </pc:graphicFrameChg>
-        <pc:graphicFrameChg chg="del">
-          <ac:chgData name="Li, Cong" userId="025630f4-267e-4cb3-8cd5-8795177f99f4" providerId="ADAL" clId="{929A2CC8-B112-421C-81E2-D5D63B23E300}" dt="2026-09-19T06:09:56.885" v="58641" actId="478"/>
-          <ac:graphicFrameMkLst>
-            <pc:docMk/>
-            <pc:sldMk cId="2592862289" sldId="639"/>
-            <ac:graphicFrameMk id="19" creationId="{A698938B-853E-1E75-B117-12B3E793046D}"/>
-          </ac:graphicFrameMkLst>
-        </pc:graphicFrameChg>
-        <pc:cxnChg chg="del mod">
-          <ac:chgData name="Li, Cong" userId="025630f4-267e-4cb3-8cd5-8795177f99f4" providerId="ADAL" clId="{929A2CC8-B112-421C-81E2-D5D63B23E300}" dt="2026-09-19T06:09:56.885" v="58641" actId="478"/>
-          <ac:cxnSpMkLst>
-            <pc:docMk/>
-            <pc:sldMk cId="2592862289" sldId="639"/>
-            <ac:cxnSpMk id="20" creationId="{9B5E4D0B-60CD-BBF1-64CB-7C91D6B84ED8}"/>
-          </ac:cxnSpMkLst>
-        </pc:cxnChg>
       </pc:sldChg>
       <pc:sldChg chg="addSp delSp modSp add mod delAnim modAnim">
         <pc:chgData name="Li, Cong" userId="025630f4-267e-4cb3-8cd5-8795177f99f4" providerId="ADAL" clId="{929A2CC8-B112-421C-81E2-D5D63B23E300}" dt="2026-09-19T06:34:49.842" v="59969" actId="20577"/>
@@ -2652,22 +1599,6 @@
             <ac:spMk id="6" creationId="{7BAD7FC6-9EB2-B3B7-6D61-24A8635817F1}"/>
           </ac:spMkLst>
         </pc:spChg>
-        <pc:spChg chg="del">
-          <ac:chgData name="Li, Cong" userId="025630f4-267e-4cb3-8cd5-8795177f99f4" providerId="ADAL" clId="{929A2CC8-B112-421C-81E2-D5D63B23E300}" dt="2026-09-19T06:24:56.587" v="59436" actId="478"/>
-          <ac:spMkLst>
-            <pc:docMk/>
-            <pc:sldMk cId="422344838" sldId="640"/>
-            <ac:spMk id="8" creationId="{71CAED26-C998-70D3-FA0A-C83439E5B52D}"/>
-          </ac:spMkLst>
-        </pc:spChg>
-        <pc:spChg chg="del mod">
-          <ac:chgData name="Li, Cong" userId="025630f4-267e-4cb3-8cd5-8795177f99f4" providerId="ADAL" clId="{929A2CC8-B112-421C-81E2-D5D63B23E300}" dt="2026-09-19T06:25:10.961" v="59438" actId="478"/>
-          <ac:spMkLst>
-            <pc:docMk/>
-            <pc:sldMk cId="422344838" sldId="640"/>
-            <ac:spMk id="12" creationId="{2596AB56-5A05-1491-5F11-9F4770EFBB8E}"/>
-          </ac:spMkLst>
-        </pc:spChg>
         <pc:spChg chg="mod">
           <ac:chgData name="Li, Cong" userId="025630f4-267e-4cb3-8cd5-8795177f99f4" providerId="ADAL" clId="{929A2CC8-B112-421C-81E2-D5D63B23E300}" dt="2026-09-19T06:29:16.631" v="59962" actId="1076"/>
           <ac:spMkLst>
@@ -2689,22 +1620,6 @@
             <pc:docMk/>
             <pc:sldMk cId="1696702995" sldId="641"/>
             <ac:spMk id="2" creationId="{118892EB-CF9F-1238-EBC3-08D59B629735}"/>
-          </ac:spMkLst>
-        </pc:spChg>
-        <pc:spChg chg="del">
-          <ac:chgData name="Li, Cong" userId="025630f4-267e-4cb3-8cd5-8795177f99f4" providerId="ADAL" clId="{929A2CC8-B112-421C-81E2-D5D63B23E300}" dt="2026-09-19T07:07:49.792" v="60700" actId="478"/>
-          <ac:spMkLst>
-            <pc:docMk/>
-            <pc:sldMk cId="1696702995" sldId="641"/>
-            <ac:spMk id="3" creationId="{06483B4C-2B51-FE91-661F-5AF7535B6EC8}"/>
-          </ac:spMkLst>
-        </pc:spChg>
-        <pc:spChg chg="add del mod">
-          <ac:chgData name="Li, Cong" userId="025630f4-267e-4cb3-8cd5-8795177f99f4" providerId="ADAL" clId="{929A2CC8-B112-421C-81E2-D5D63B23E300}" dt="2026-09-19T07:07:54.378" v="60701" actId="478"/>
-          <ac:spMkLst>
-            <pc:docMk/>
-            <pc:sldMk cId="1696702995" sldId="641"/>
-            <ac:spMk id="4" creationId="{4A8784CA-4CD1-23B7-AC28-F6754B9E050A}"/>
           </ac:spMkLst>
         </pc:spChg>
         <pc:spChg chg="add mod">
@@ -2746,14 +1661,6 @@
             <ac:spMk id="3" creationId="{893BDCC6-D31C-849E-0429-A434AA206852}"/>
           </ac:spMkLst>
         </pc:spChg>
-        <pc:spChg chg="del">
-          <ac:chgData name="Li, Cong" userId="025630f4-267e-4cb3-8cd5-8795177f99f4" providerId="ADAL" clId="{929A2CC8-B112-421C-81E2-D5D63B23E300}" dt="2026-09-19T07:21:03.662" v="61448" actId="478"/>
-          <ac:spMkLst>
-            <pc:docMk/>
-            <pc:sldMk cId="2652500846" sldId="642"/>
-            <ac:spMk id="4" creationId="{5C5ED9BA-BDA3-5C1C-28FB-00BA035D43BD}"/>
-          </ac:spMkLst>
-        </pc:spChg>
         <pc:spChg chg="mod">
           <ac:chgData name="Li, Cong" userId="025630f4-267e-4cb3-8cd5-8795177f99f4" providerId="ADAL" clId="{929A2CC8-B112-421C-81E2-D5D63B23E300}" dt="2026-09-19T07:21:07.721" v="61450" actId="1036"/>
           <ac:spMkLst>
@@ -2768,6 +1675,45 @@
             <pc:docMk/>
             <pc:sldMk cId="2652500846" sldId="642"/>
             <ac:spMk id="13" creationId="{F25B2D59-B124-BB92-EC36-C51D325BC71B}"/>
+          </ac:spMkLst>
+        </pc:spChg>
+      </pc:sldChg>
+      <pc:sldChg chg="modSp add mod modAnim">
+        <pc:chgData name="Li, Cong" userId="025630f4-267e-4cb3-8cd5-8795177f99f4" providerId="ADAL" clId="{929A2CC8-B112-421C-81E2-D5D63B23E300}" dt="2026-09-25T06:28:00.661" v="61719" actId="1076"/>
+        <pc:sldMkLst>
+          <pc:docMk/>
+          <pc:sldMk cId="4156585488" sldId="643"/>
+        </pc:sldMkLst>
+        <pc:spChg chg="mod">
+          <ac:chgData name="Li, Cong" userId="025630f4-267e-4cb3-8cd5-8795177f99f4" providerId="ADAL" clId="{929A2CC8-B112-421C-81E2-D5D63B23E300}" dt="2026-09-25T06:25:59.150" v="61613" actId="20577"/>
+          <ac:spMkLst>
+            <pc:docMk/>
+            <pc:sldMk cId="4156585488" sldId="643"/>
+            <ac:spMk id="2" creationId="{7E837C18-1406-3DE5-D8F9-062D43C82985}"/>
+          </ac:spMkLst>
+        </pc:spChg>
+        <pc:spChg chg="mod">
+          <ac:chgData name="Li, Cong" userId="025630f4-267e-4cb3-8cd5-8795177f99f4" providerId="ADAL" clId="{929A2CC8-B112-421C-81E2-D5D63B23E300}" dt="2026-09-25T06:27:41.838" v="61718" actId="1036"/>
+          <ac:spMkLst>
+            <pc:docMk/>
+            <pc:sldMk cId="4156585488" sldId="643"/>
+            <ac:spMk id="3" creationId="{3FA10E85-0B8B-2977-5344-100082AE72C9}"/>
+          </ac:spMkLst>
+        </pc:spChg>
+        <pc:spChg chg="mod">
+          <ac:chgData name="Li, Cong" userId="025630f4-267e-4cb3-8cd5-8795177f99f4" providerId="ADAL" clId="{929A2CC8-B112-421C-81E2-D5D63B23E300}" dt="2026-09-25T06:28:00.661" v="61719" actId="1076"/>
+          <ac:spMkLst>
+            <pc:docMk/>
+            <pc:sldMk cId="4156585488" sldId="643"/>
+            <ac:spMk id="6" creationId="{AC0D1BAD-1D38-AFE1-CE07-DD3120CEAAD6}"/>
+          </ac:spMkLst>
+        </pc:spChg>
+        <pc:spChg chg="mod">
+          <ac:chgData name="Li, Cong" userId="025630f4-267e-4cb3-8cd5-8795177f99f4" providerId="ADAL" clId="{929A2CC8-B112-421C-81E2-D5D63B23E300}" dt="2026-09-25T06:27:41.838" v="61718" actId="1036"/>
+          <ac:spMkLst>
+            <pc:docMk/>
+            <pc:sldMk cId="4156585488" sldId="643"/>
+            <ac:spMk id="13" creationId="{5C8BD6AB-F2AA-409F-2E76-080CC72B6017}"/>
           </ac:spMkLst>
         </pc:spChg>
       </pc:sldChg>
@@ -3892,7 +2838,7 @@
                 <a:latin typeface="Arial" panose="020B0604020202020204" pitchFamily="34" charset="0"/>
               </a:rPr>
               <a:pPr/>
-              <a:t>28</a:t>
+              <a:t>29</a:t>
             </a:fld>
             <a:endParaRPr lang="en-US" altLang="zh-CN">
               <a:latin typeface="Arial" panose="020B0604020202020204" pitchFamily="34" charset="0"/>
@@ -23360,6 +22306,443 @@
 </file>
 
 <file path=ppt/slides/slide28.xml><?xml version="1.0" encoding="utf-8"?>
+<p:sld xmlns:a="http://schemas.openxmlformats.org/drawingml/2006/main" xmlns:r="http://schemas.openxmlformats.org/officeDocument/2006/relationships" xmlns:p="http://schemas.openxmlformats.org/presentationml/2006/main">
+  <p:cSld>
+    <p:spTree>
+      <p:nvGrpSpPr>
+        <p:cNvPr id="1" name="">
+          <a:extLst>
+            <a:ext uri="{FF2B5EF4-FFF2-40B4-BE49-F238E27FC236}">
+              <a16:creationId xmlns:a16="http://schemas.microsoft.com/office/drawing/2014/main" id="{ED2E9C25-FEEC-A76A-7EFA-420DEBD9BC70}"/>
+            </a:ext>
+          </a:extLst>
+        </p:cNvPr>
+        <p:cNvGrpSpPr/>
+        <p:nvPr/>
+      </p:nvGrpSpPr>
+      <p:grpSpPr>
+        <a:xfrm>
+          <a:off x="0" y="0"/>
+          <a:ext cx="0" cy="0"/>
+          <a:chOff x="0" y="0"/>
+          <a:chExt cx="0" cy="0"/>
+        </a:xfrm>
+      </p:grpSpPr>
+      <p:sp>
+        <p:nvSpPr>
+          <p:cNvPr id="2" name="Title 1">
+            <a:extLst>
+              <a:ext uri="{FF2B5EF4-FFF2-40B4-BE49-F238E27FC236}">
+                <a16:creationId xmlns:a16="http://schemas.microsoft.com/office/drawing/2014/main" id="{7E837C18-1406-3DE5-D8F9-062D43C82985}"/>
+              </a:ext>
+            </a:extLst>
+          </p:cNvPr>
+          <p:cNvSpPr>
+            <a:spLocks noGrp="1"/>
+          </p:cNvSpPr>
+          <p:nvPr>
+            <p:ph type="title"/>
+          </p:nvPr>
+        </p:nvSpPr>
+        <p:spPr/>
+        <p:txBody>
+          <a:bodyPr/>
+          <a:lstStyle/>
+          <a:p>
+            <a:r>
+              <a:rPr lang="en-US" altLang="zh-CN" dirty="0"/>
+              <a:t>Low Precision  </a:t>
+            </a:r>
+            <a:r>
+              <a:rPr lang="zh-CN" altLang="en-US" dirty="0"/>
+              <a:t>低精度</a:t>
+            </a:r>
+          </a:p>
+        </p:txBody>
+      </p:sp>
+      <p:sp>
+        <p:nvSpPr>
+          <p:cNvPr id="5" name="Footer Placeholder 3">
+            <a:extLst>
+              <a:ext uri="{FF2B5EF4-FFF2-40B4-BE49-F238E27FC236}">
+                <a16:creationId xmlns:a16="http://schemas.microsoft.com/office/drawing/2014/main" id="{1284AAB7-BE6C-63CC-A59C-A8AA5335C074}"/>
+              </a:ext>
+            </a:extLst>
+          </p:cNvPr>
+          <p:cNvSpPr>
+            <a:spLocks noGrp="1"/>
+          </p:cNvSpPr>
+          <p:nvPr>
+            <p:ph type="ftr" sz="quarter" idx="10"/>
+          </p:nvPr>
+        </p:nvSpPr>
+        <p:spPr>
+          <a:xfrm>
+            <a:off x="685800" y="6324600"/>
+            <a:ext cx="7772400" cy="457200"/>
+          </a:xfrm>
+        </p:spPr>
+        <p:txBody>
+          <a:bodyPr/>
+          <a:lstStyle/>
+          <a:p>
+            <a:pPr>
+              <a:defRPr/>
+            </a:pPr>
+            <a:r>
+              <a:rPr lang="en-US" altLang="zh-CN" dirty="0"/>
+              <a:t>How Computing Works - Modern Paradigms of Architecture &amp; System: 6. Low Precision</a:t>
+            </a:r>
+          </a:p>
+          <a:p>
+            <a:pPr>
+              <a:defRPr/>
+            </a:pPr>
+            <a:r>
+              <a:rPr lang="zh-CN" altLang="en-US" dirty="0"/>
+              <a:t>计算如何运作 </a:t>
+            </a:r>
+            <a:r>
+              <a:rPr lang="en-US" altLang="zh-CN" dirty="0"/>
+              <a:t>– </a:t>
+            </a:r>
+            <a:r>
+              <a:rPr lang="zh-CN" altLang="en-US" dirty="0"/>
+              <a:t>架构与系统的现代范式： </a:t>
+            </a:r>
+            <a:r>
+              <a:rPr lang="en-US" altLang="zh-CN" dirty="0"/>
+              <a:t>6. </a:t>
+            </a:r>
+            <a:r>
+              <a:rPr lang="zh-CN" altLang="en-US" dirty="0"/>
+              <a:t>低精度</a:t>
+            </a:r>
+            <a:endParaRPr lang="en-US" altLang="zh-CN" dirty="0"/>
+          </a:p>
+        </p:txBody>
+      </p:sp>
+      <p:sp>
+        <p:nvSpPr>
+          <p:cNvPr id="6" name="TextBox 5">
+            <a:extLst>
+              <a:ext uri="{FF2B5EF4-FFF2-40B4-BE49-F238E27FC236}">
+                <a16:creationId xmlns:a16="http://schemas.microsoft.com/office/drawing/2014/main" id="{AC0D1BAD-1D38-AFE1-CE07-DD3120CEAAD6}"/>
+              </a:ext>
+            </a:extLst>
+          </p:cNvPr>
+          <p:cNvSpPr txBox="1"/>
+          <p:nvPr/>
+        </p:nvSpPr>
+        <p:spPr>
+          <a:xfrm>
+            <a:off x="152399" y="1785996"/>
+            <a:ext cx="8839200" cy="830997"/>
+          </a:xfrm>
+          <a:prstGeom prst="rect">
+            <a:avLst/>
+          </a:prstGeom>
+          <a:noFill/>
+        </p:spPr>
+        <p:txBody>
+          <a:bodyPr wrap="square" rtlCol="0">
+            <a:spAutoFit/>
+          </a:bodyPr>
+          <a:lstStyle/>
+          <a:p>
+            <a:pPr algn="ctr"/>
+            <a:r>
+              <a:rPr lang="en-US" altLang="zh-CN" sz="2400" dirty="0"/>
+              <a:t>It’s a seemingly simple idea  </a:t>
+            </a:r>
+          </a:p>
+          <a:p>
+            <a:pPr algn="ctr"/>
+            <a:r>
+              <a:rPr lang="zh-CN" altLang="en-US" sz="2400" dirty="0"/>
+              <a:t>这是个看起来简单的想法</a:t>
+            </a:r>
+          </a:p>
+        </p:txBody>
+      </p:sp>
+      <p:sp>
+        <p:nvSpPr>
+          <p:cNvPr id="13" name="TextBox 12">
+            <a:extLst>
+              <a:ext uri="{FF2B5EF4-FFF2-40B4-BE49-F238E27FC236}">
+                <a16:creationId xmlns:a16="http://schemas.microsoft.com/office/drawing/2014/main" id="{5C8BD6AB-F2AA-409F-2E76-080CC72B6017}"/>
+              </a:ext>
+            </a:extLst>
+          </p:cNvPr>
+          <p:cNvSpPr txBox="1"/>
+          <p:nvPr/>
+        </p:nvSpPr>
+        <p:spPr>
+          <a:xfrm>
+            <a:off x="307656" y="3118068"/>
+            <a:ext cx="8528685" cy="830997"/>
+          </a:xfrm>
+          <a:prstGeom prst="rect">
+            <a:avLst/>
+          </a:prstGeom>
+          <a:noFill/>
+        </p:spPr>
+        <p:txBody>
+          <a:bodyPr wrap="square" rtlCol="0">
+            <a:spAutoFit/>
+          </a:bodyPr>
+          <a:lstStyle/>
+          <a:p>
+            <a:pPr algn="ctr"/>
+            <a:r>
+              <a:rPr lang="en-US" altLang="zh-CN" sz="2400" dirty="0"/>
+              <a:t>This is a simplified picture w/o touch many complexities</a:t>
+            </a:r>
+          </a:p>
+          <a:p>
+            <a:pPr algn="ctr"/>
+            <a:r>
+              <a:rPr lang="zh-CN" altLang="en-US" sz="2400" dirty="0"/>
+              <a:t>这是一个简化的图景，并未触及很多复杂性</a:t>
+            </a:r>
+          </a:p>
+        </p:txBody>
+      </p:sp>
+      <p:sp>
+        <p:nvSpPr>
+          <p:cNvPr id="3" name="TextBox 2">
+            <a:extLst>
+              <a:ext uri="{FF2B5EF4-FFF2-40B4-BE49-F238E27FC236}">
+                <a16:creationId xmlns:a16="http://schemas.microsoft.com/office/drawing/2014/main" id="{3FA10E85-0B8B-2977-5344-100082AE72C9}"/>
+              </a:ext>
+            </a:extLst>
+          </p:cNvPr>
+          <p:cNvSpPr txBox="1"/>
+          <p:nvPr/>
+        </p:nvSpPr>
+        <p:spPr>
+          <a:xfrm>
+            <a:off x="152400" y="4450140"/>
+            <a:ext cx="8839199" cy="1569660"/>
+          </a:xfrm>
+          <a:prstGeom prst="rect">
+            <a:avLst/>
+          </a:prstGeom>
+          <a:noFill/>
+        </p:spPr>
+        <p:txBody>
+          <a:bodyPr wrap="square" rtlCol="0">
+            <a:spAutoFit/>
+          </a:bodyPr>
+          <a:lstStyle/>
+          <a:p>
+            <a:pPr algn="ctr"/>
+            <a:r>
+              <a:rPr lang="en-US" altLang="zh-CN" sz="2400" dirty="0"/>
+              <a:t>It’s practical &amp; popular, but only w/ the right error tolerance &amp; the right hardware-software acceleration</a:t>
+            </a:r>
+          </a:p>
+          <a:p>
+            <a:pPr algn="ctr"/>
+            <a:r>
+              <a:rPr lang="zh-CN" altLang="en-US" sz="2400" dirty="0"/>
+              <a:t>当我们能正确地容忍误差、并合理地进行软硬件加速时，</a:t>
+            </a:r>
+            <a:endParaRPr lang="en-US" altLang="zh-CN" sz="2400" dirty="0"/>
+          </a:p>
+          <a:p>
+            <a:pPr algn="ctr"/>
+            <a:r>
+              <a:rPr lang="zh-CN" altLang="en-US" sz="2400" dirty="0"/>
+              <a:t>低精度能展现出其实用性，并流行于世</a:t>
+            </a:r>
+          </a:p>
+        </p:txBody>
+      </p:sp>
+    </p:spTree>
+    <p:extLst>
+      <p:ext uri="{BB962C8B-B14F-4D97-AF65-F5344CB8AC3E}">
+        <p14:creationId xmlns:p14="http://schemas.microsoft.com/office/powerpoint/2010/main" val="4156585488"/>
+      </p:ext>
+    </p:extLst>
+  </p:cSld>
+  <p:clrMapOvr>
+    <a:masterClrMapping/>
+  </p:clrMapOvr>
+  <p:timing>
+    <p:tnLst>
+      <p:par>
+        <p:cTn id="1" dur="indefinite" restart="never" nodeType="tmRoot">
+          <p:childTnLst>
+            <p:seq concurrent="1" nextAc="seek">
+              <p:cTn id="2" dur="indefinite" nodeType="mainSeq">
+                <p:childTnLst>
+                  <p:par>
+                    <p:cTn id="3" fill="hold">
+                      <p:stCondLst>
+                        <p:cond delay="indefinite"/>
+                      </p:stCondLst>
+                      <p:childTnLst>
+                        <p:par>
+                          <p:cTn id="4" fill="hold">
+                            <p:stCondLst>
+                              <p:cond delay="0"/>
+                            </p:stCondLst>
+                            <p:childTnLst>
+                              <p:par>
+                                <p:cTn id="5" presetID="1" presetClass="entr" presetSubtype="0" fill="hold" grpId="0" nodeType="clickEffect">
+                                  <p:stCondLst>
+                                    <p:cond delay="0"/>
+                                  </p:stCondLst>
+                                  <p:childTnLst>
+                                    <p:set>
+                                      <p:cBhvr>
+                                        <p:cTn id="6" dur="1" fill="hold">
+                                          <p:stCondLst>
+                                            <p:cond delay="0"/>
+                                          </p:stCondLst>
+                                        </p:cTn>
+                                        <p:tgtEl>
+                                          <p:spTgt spid="6"/>
+                                        </p:tgtEl>
+                                        <p:attrNameLst>
+                                          <p:attrName>style.visibility</p:attrName>
+                                        </p:attrNameLst>
+                                      </p:cBhvr>
+                                      <p:to>
+                                        <p:strVal val="visible"/>
+                                      </p:to>
+                                    </p:set>
+                                  </p:childTnLst>
+                                </p:cTn>
+                              </p:par>
+                            </p:childTnLst>
+                          </p:cTn>
+                        </p:par>
+                      </p:childTnLst>
+                    </p:cTn>
+                  </p:par>
+                  <p:par>
+                    <p:cTn id="7" fill="hold">
+                      <p:stCondLst>
+                        <p:cond delay="indefinite"/>
+                      </p:stCondLst>
+                      <p:childTnLst>
+                        <p:par>
+                          <p:cTn id="8" fill="hold">
+                            <p:stCondLst>
+                              <p:cond delay="0"/>
+                            </p:stCondLst>
+                            <p:childTnLst>
+                              <p:par>
+                                <p:cTn id="9" presetID="1" presetClass="entr" presetSubtype="0" fill="hold" grpId="0" nodeType="clickEffect">
+                                  <p:stCondLst>
+                                    <p:cond delay="0"/>
+                                  </p:stCondLst>
+                                  <p:childTnLst>
+                                    <p:set>
+                                      <p:cBhvr>
+                                        <p:cTn id="10" dur="1" fill="hold">
+                                          <p:stCondLst>
+                                            <p:cond delay="0"/>
+                                          </p:stCondLst>
+                                        </p:cTn>
+                                        <p:tgtEl>
+                                          <p:spTgt spid="13"/>
+                                        </p:tgtEl>
+                                        <p:attrNameLst>
+                                          <p:attrName>style.visibility</p:attrName>
+                                        </p:attrNameLst>
+                                      </p:cBhvr>
+                                      <p:to>
+                                        <p:strVal val="visible"/>
+                                      </p:to>
+                                    </p:set>
+                                  </p:childTnLst>
+                                </p:cTn>
+                              </p:par>
+                            </p:childTnLst>
+                          </p:cTn>
+                        </p:par>
+                      </p:childTnLst>
+                    </p:cTn>
+                  </p:par>
+                  <p:par>
+                    <p:cTn id="11" fill="hold">
+                      <p:stCondLst>
+                        <p:cond delay="indefinite"/>
+                      </p:stCondLst>
+                      <p:childTnLst>
+                        <p:par>
+                          <p:cTn id="12" fill="hold">
+                            <p:stCondLst>
+                              <p:cond delay="0"/>
+                            </p:stCondLst>
+                            <p:childTnLst>
+                              <p:par>
+                                <p:cTn id="13" presetID="1" presetClass="entr" presetSubtype="0" fill="hold" grpId="0" nodeType="clickEffect">
+                                  <p:stCondLst>
+                                    <p:cond delay="0"/>
+                                  </p:stCondLst>
+                                  <p:childTnLst>
+                                    <p:set>
+                                      <p:cBhvr>
+                                        <p:cTn id="14" dur="1" fill="hold">
+                                          <p:stCondLst>
+                                            <p:cond delay="0"/>
+                                          </p:stCondLst>
+                                        </p:cTn>
+                                        <p:tgtEl>
+                                          <p:spTgt spid="3"/>
+                                        </p:tgtEl>
+                                        <p:attrNameLst>
+                                          <p:attrName>style.visibility</p:attrName>
+                                        </p:attrNameLst>
+                                      </p:cBhvr>
+                                      <p:to>
+                                        <p:strVal val="visible"/>
+                                      </p:to>
+                                    </p:set>
+                                  </p:childTnLst>
+                                </p:cTn>
+                              </p:par>
+                            </p:childTnLst>
+                          </p:cTn>
+                        </p:par>
+                      </p:childTnLst>
+                    </p:cTn>
+                  </p:par>
+                </p:childTnLst>
+              </p:cTn>
+              <p:prevCondLst>
+                <p:cond evt="onPrev" delay="0">
+                  <p:tgtEl>
+                    <p:sldTgt/>
+                  </p:tgtEl>
+                </p:cond>
+              </p:prevCondLst>
+              <p:nextCondLst>
+                <p:cond evt="onNext" delay="0">
+                  <p:tgtEl>
+                    <p:sldTgt/>
+                  </p:tgtEl>
+                </p:cond>
+              </p:nextCondLst>
+            </p:seq>
+          </p:childTnLst>
+        </p:cTn>
+      </p:par>
+    </p:tnLst>
+    <p:bldLst>
+      <p:bldP spid="6" grpId="0"/>
+      <p:bldP spid="13" grpId="0" uiExpand="1"/>
+      <p:bldP spid="3" grpId="0" uiExpand="1"/>
+    </p:bldLst>
+  </p:timing>
+</p:sld>
+</file>
+
+<file path=ppt/slides/slide29.xml><?xml version="1.0" encoding="utf-8"?>
 <p:sld xmlns:a="http://schemas.openxmlformats.org/drawingml/2006/main" xmlns:r="http://schemas.openxmlformats.org/officeDocument/2006/relationships" xmlns:p="http://schemas.openxmlformats.org/presentationml/2006/main">
   <p:cSld>
     <p:spTree>
@@ -29695,6 +29078,15 @@
 </file>
 
 <file path=customXml/item1.xml><?xml version="1.0" encoding="utf-8"?>
+<?mso-contentType ?>
+<FormTemplates xmlns="http://schemas.microsoft.com/sharepoint/v3/contenttype/forms">
+  <Display>DocumentLibraryForm</Display>
+  <Edit>DocumentLibraryForm</Edit>
+  <New>DocumentLibraryForm</New>
+</FormTemplates>
+</file>
+
+<file path=customXml/item2.xml><?xml version="1.0" encoding="utf-8"?>
 <ct:contentTypeSchema xmlns:ct="http://schemas.microsoft.com/office/2006/metadata/contentType" xmlns:ma="http://schemas.microsoft.com/office/2006/metadata/properties/metaAttributes" ct:_="" ma:_="" ma:contentTypeName="Document" ma:contentTypeID="0x0101007C40B1A4C5819246B9BFCCBA066F3ABE" ma:contentTypeVersion="19" ma:contentTypeDescription="Create a new document." ma:contentTypeScope="" ma:versionID="9692fad3877e1ae90f51e4baed900726">
   <xsd:schema xmlns:xsd="http://www.w3.org/2001/XMLSchema" xmlns:xs="http://www.w3.org/2001/XMLSchema" xmlns:p="http://schemas.microsoft.com/office/2006/metadata/properties" xmlns:ns3="96e2f25c-537a-4a0c-91fb-0331a5612536" xmlns:ns4="f66673be-3b20-4ac8-ba7c-00310aa8f626" targetNamespace="http://schemas.microsoft.com/office/2006/metadata/properties" ma:root="true" ma:fieldsID="a4d7b83b6d623c2308b23cc2086510ce" ns3:_="" ns4:_="">
     <xsd:import namespace="96e2f25c-537a-4a0c-91fb-0331a5612536"/>
@@ -29953,15 +29345,6 @@
 </ct:contentTypeSchema>
 </file>
 
-<file path=customXml/item2.xml><?xml version="1.0" encoding="utf-8"?>
-<?mso-contentType ?>
-<FormTemplates xmlns="http://schemas.microsoft.com/sharepoint/v3/contenttype/forms">
-  <Display>DocumentLibraryForm</Display>
-  <Edit>DocumentLibraryForm</Edit>
-  <New>DocumentLibraryForm</New>
-</FormTemplates>
-</file>
-
 <file path=customXml/item3.xml><?xml version="1.0" encoding="utf-8"?>
 <p:properties xmlns:p="http://schemas.microsoft.com/office/2006/metadata/properties" xmlns:xsi="http://www.w3.org/2001/XMLSchema-instance" xmlns:pc="http://schemas.microsoft.com/office/infopath/2007/PartnerControls">
   <documentManagement>
@@ -29971,6 +29354,14 @@
 </file>
 
 <file path=customXml/itemProps1.xml><?xml version="1.0" encoding="utf-8"?>
+<ds:datastoreItem xmlns:ds="http://schemas.openxmlformats.org/officeDocument/2006/customXml" ds:itemID="{C0A29639-2C97-4587-B7DD-B53C30F641B7}">
+  <ds:schemaRefs>
+    <ds:schemaRef ds:uri="http://schemas.microsoft.com/sharepoint/v3/contenttype/forms"/>
+  </ds:schemaRefs>
+</ds:datastoreItem>
+</file>
+
+<file path=customXml/itemProps2.xml><?xml version="1.0" encoding="utf-8"?>
 <ds:datastoreItem xmlns:ds="http://schemas.openxmlformats.org/officeDocument/2006/customXml" ds:itemID="{AF88747F-F311-4A49-9509-54EE6A6EEAAB}">
   <ds:schemaRefs>
     <ds:schemaRef ds:uri="http://schemas.microsoft.com/office/2006/metadata/contentType"/>
@@ -29985,14 +29376,6 @@
     <ds:schemaRef ds:uri="http://purl.org/dc/elements/1.1/"/>
     <ds:schemaRef ds:uri="http://purl.org/dc/terms/"/>
     <ds:schemaRef ds:uri="http://schemas.microsoft.com/internal/obd"/>
-  </ds:schemaRefs>
-</ds:datastoreItem>
-</file>
-
-<file path=customXml/itemProps2.xml><?xml version="1.0" encoding="utf-8"?>
-<ds:datastoreItem xmlns:ds="http://schemas.openxmlformats.org/officeDocument/2006/customXml" ds:itemID="{C0A29639-2C97-4587-B7DD-B53C30F641B7}">
-  <ds:schemaRefs>
-    <ds:schemaRef ds:uri="http://schemas.microsoft.com/sharepoint/v3/contenttype/forms"/>
   </ds:schemaRefs>
 </ds:datastoreItem>
 </file>

</xml_diff>